<commit_message>
feat(guides,production): path from requirement to code, spec terms, question checks
- Principles 7: invariant spine (requirement -> user story with acceptance
  criteria -> code/tests), intermediate artifacts chosen on two axes
  (domain/technical complexity), what/when/how long; a spec is the
  requirements definition under a new name; domain model and architecture
  are referenced, not part of the spec.
- Authoring guide: path placement, no self-referring filler, session
  references by name only, clear table column names, spec terms
  (유저 스토리, 수용 기준, 요구사항 정의서, 작업 명세서).
- Course design guide: path in course context; legacy course designs marked.
- Production: warn on question titles/table cells without "?"; decks outside
  a course need no next session; practice explanation font fix.
- verify-quote: ligature and spacing normalization; 60+ OOAD quotes verified.
- references/inputs/ (received originals) is git-ignored.

Co-Authored-By: Claude Opus 5.5 <noreply@anthropic.com>
</commit_message>
<xml_diff>
--- a/references/sw-engineering-approach/sw-engineering-approach.pptx
+++ b/references/sw-engineering-approach/sw-engineering-approach.pptx
@@ -417,7 +417,7 @@
   </p:cSld>
   <p:clrMap bg1="lt1" tx1="dk1" bg2="lt2" tx2="dk2" accent1="accent1" accent2="accent2" accent3="accent3" accent4="accent4" accent5="accent5" accent6="accent6" hlink="hlink" folHlink="folHlink"/>
   <p:notesStyle>
-    <a:lvl1pPr marL="0" algn="l" defTabSz="914400" rtl="0" eaLnBrk="1" latinLnBrk="1" hangingPunct="1">
+    <a:lvl1pPr marL="0" algn="l" defTabSz="914400" rtl="0" eaLnBrk="1" latinLnBrk="0" hangingPunct="1">
       <a:defRPr sz="1200" kern="1200">
         <a:solidFill>
           <a:schemeClr val="tx1"/>
@@ -427,7 +427,7 @@
         <a:cs typeface="+mn-cs"/>
       </a:defRPr>
     </a:lvl1pPr>
-    <a:lvl2pPr marL="457200" algn="l" defTabSz="914400" rtl="0" eaLnBrk="1" latinLnBrk="1" hangingPunct="1">
+    <a:lvl2pPr marL="457200" algn="l" defTabSz="914400" rtl="0" eaLnBrk="1" latinLnBrk="0" hangingPunct="1">
       <a:defRPr sz="1200" kern="1200">
         <a:solidFill>
           <a:schemeClr val="tx1"/>
@@ -437,7 +437,7 @@
         <a:cs typeface="+mn-cs"/>
       </a:defRPr>
     </a:lvl2pPr>
-    <a:lvl3pPr marL="914400" algn="l" defTabSz="914400" rtl="0" eaLnBrk="1" latinLnBrk="1" hangingPunct="1">
+    <a:lvl3pPr marL="914400" algn="l" defTabSz="914400" rtl="0" eaLnBrk="1" latinLnBrk="0" hangingPunct="1">
       <a:defRPr sz="1200" kern="1200">
         <a:solidFill>
           <a:schemeClr val="tx1"/>
@@ -447,7 +447,7 @@
         <a:cs typeface="+mn-cs"/>
       </a:defRPr>
     </a:lvl3pPr>
-    <a:lvl4pPr marL="1371600" algn="l" defTabSz="914400" rtl="0" eaLnBrk="1" latinLnBrk="1" hangingPunct="1">
+    <a:lvl4pPr marL="1371600" algn="l" defTabSz="914400" rtl="0" eaLnBrk="1" latinLnBrk="0" hangingPunct="1">
       <a:defRPr sz="1200" kern="1200">
         <a:solidFill>
           <a:schemeClr val="tx1"/>
@@ -457,7 +457,7 @@
         <a:cs typeface="+mn-cs"/>
       </a:defRPr>
     </a:lvl4pPr>
-    <a:lvl5pPr marL="1828800" algn="l" defTabSz="914400" rtl="0" eaLnBrk="1" latinLnBrk="1" hangingPunct="1">
+    <a:lvl5pPr marL="1828800" algn="l" defTabSz="914400" rtl="0" eaLnBrk="1" latinLnBrk="0" hangingPunct="1">
       <a:defRPr sz="1200" kern="1200">
         <a:solidFill>
           <a:schemeClr val="tx1"/>
@@ -467,7 +467,7 @@
         <a:cs typeface="+mn-cs"/>
       </a:defRPr>
     </a:lvl5pPr>
-    <a:lvl6pPr marL="2286000" algn="l" defTabSz="914400" rtl="0" eaLnBrk="1" latinLnBrk="1" hangingPunct="1">
+    <a:lvl6pPr marL="2286000" algn="l" defTabSz="914400" rtl="0" eaLnBrk="1" latinLnBrk="0" hangingPunct="1">
       <a:defRPr sz="1200" kern="1200">
         <a:solidFill>
           <a:schemeClr val="tx1"/>
@@ -477,7 +477,7 @@
         <a:cs typeface="+mn-cs"/>
       </a:defRPr>
     </a:lvl6pPr>
-    <a:lvl7pPr marL="2743200" algn="l" defTabSz="914400" rtl="0" eaLnBrk="1" latinLnBrk="1" hangingPunct="1">
+    <a:lvl7pPr marL="2743200" algn="l" defTabSz="914400" rtl="0" eaLnBrk="1" latinLnBrk="0" hangingPunct="1">
       <a:defRPr sz="1200" kern="1200">
         <a:solidFill>
           <a:schemeClr val="tx1"/>
@@ -487,7 +487,7 @@
         <a:cs typeface="+mn-cs"/>
       </a:defRPr>
     </a:lvl7pPr>
-    <a:lvl8pPr marL="3200400" algn="l" defTabSz="914400" rtl="0" eaLnBrk="1" latinLnBrk="1" hangingPunct="1">
+    <a:lvl8pPr marL="3200400" algn="l" defTabSz="914400" rtl="0" eaLnBrk="1" latinLnBrk="0" hangingPunct="1">
       <a:defRPr sz="1200" kern="1200">
         <a:solidFill>
           <a:schemeClr val="tx1"/>
@@ -497,7 +497,7 @@
         <a:cs typeface="+mn-cs"/>
       </a:defRPr>
     </a:lvl8pPr>
-    <a:lvl9pPr marL="3657600" algn="l" defTabSz="914400" rtl="0" eaLnBrk="1" latinLnBrk="1" hangingPunct="1">
+    <a:lvl9pPr marL="3657600" algn="l" defTabSz="914400" rtl="0" eaLnBrk="1" latinLnBrk="0" hangingPunct="1">
       <a:defRPr sz="1200" kern="1200">
         <a:solidFill>
           <a:schemeClr val="tx1"/>
@@ -1237,7 +1237,7 @@
   <p:hf hdr="0" ftr="0" dt="0"/>
   <p:txStyles>
     <p:titleStyle>
-      <a:lvl1pPr algn="l" rtl="0" eaLnBrk="0" fontAlgn="base" latinLnBrk="1" hangingPunct="0">
+      <a:lvl1pPr algn="l" rtl="0" eaLnBrk="0" fontAlgn="base" latinLnBrk="0" hangingPunct="0">
         <a:spcBef>
           <a:spcPct val="0"/>
         </a:spcBef>
@@ -1253,7 +1253,7 @@
           <a:cs typeface="+mj-cs"/>
         </a:defRPr>
       </a:lvl1pPr>
-      <a:lvl2pPr algn="l" rtl="0" eaLnBrk="0" fontAlgn="base" latinLnBrk="1" hangingPunct="0">
+      <a:lvl2pPr algn="l" rtl="0" eaLnBrk="0" fontAlgn="base" latinLnBrk="0" hangingPunct="0">
         <a:spcBef>
           <a:spcPct val="0"/>
         </a:spcBef>
@@ -1268,7 +1268,7 @@
           <a:ea typeface="맑은 고딕" pitchFamily="50" charset="-127"/>
         </a:defRPr>
       </a:lvl2pPr>
-      <a:lvl3pPr algn="l" rtl="0" eaLnBrk="0" fontAlgn="base" latinLnBrk="1" hangingPunct="0">
+      <a:lvl3pPr algn="l" rtl="0" eaLnBrk="0" fontAlgn="base" latinLnBrk="0" hangingPunct="0">
         <a:spcBef>
           <a:spcPct val="0"/>
         </a:spcBef>
@@ -1283,7 +1283,7 @@
           <a:ea typeface="맑은 고딕" pitchFamily="50" charset="-127"/>
         </a:defRPr>
       </a:lvl3pPr>
-      <a:lvl4pPr algn="l" rtl="0" eaLnBrk="0" fontAlgn="base" latinLnBrk="1" hangingPunct="0">
+      <a:lvl4pPr algn="l" rtl="0" eaLnBrk="0" fontAlgn="base" latinLnBrk="0" hangingPunct="0">
         <a:spcBef>
           <a:spcPct val="0"/>
         </a:spcBef>
@@ -1298,7 +1298,7 @@
           <a:ea typeface="맑은 고딕" pitchFamily="50" charset="-127"/>
         </a:defRPr>
       </a:lvl4pPr>
-      <a:lvl5pPr algn="l" rtl="0" eaLnBrk="0" fontAlgn="base" latinLnBrk="1" hangingPunct="0">
+      <a:lvl5pPr algn="l" rtl="0" eaLnBrk="0" fontAlgn="base" latinLnBrk="0" hangingPunct="0">
         <a:spcBef>
           <a:spcPct val="0"/>
         </a:spcBef>
@@ -1313,7 +1313,7 @@
           <a:ea typeface="맑은 고딕" pitchFamily="50" charset="-127"/>
         </a:defRPr>
       </a:lvl5pPr>
-      <a:lvl6pPr marL="457200" algn="ctr" rtl="0" fontAlgn="base" latinLnBrk="1">
+      <a:lvl6pPr marL="457200" algn="ctr" rtl="0" fontAlgn="base" latinLnBrk="0">
         <a:spcBef>
           <a:spcPct val="0"/>
         </a:spcBef>
@@ -1328,7 +1328,7 @@
           <a:ea typeface="맑은 고딕" pitchFamily="50" charset="-127"/>
         </a:defRPr>
       </a:lvl6pPr>
-      <a:lvl7pPr marL="914400" algn="ctr" rtl="0" fontAlgn="base" latinLnBrk="1">
+      <a:lvl7pPr marL="914400" algn="ctr" rtl="0" fontAlgn="base" latinLnBrk="0">
         <a:spcBef>
           <a:spcPct val="0"/>
         </a:spcBef>
@@ -1343,7 +1343,7 @@
           <a:ea typeface="맑은 고딕" pitchFamily="50" charset="-127"/>
         </a:defRPr>
       </a:lvl7pPr>
-      <a:lvl8pPr marL="1371600" algn="ctr" rtl="0" fontAlgn="base" latinLnBrk="1">
+      <a:lvl8pPr marL="1371600" algn="ctr" rtl="0" fontAlgn="base" latinLnBrk="0">
         <a:spcBef>
           <a:spcPct val="0"/>
         </a:spcBef>
@@ -1358,7 +1358,7 @@
           <a:ea typeface="맑은 고딕" pitchFamily="50" charset="-127"/>
         </a:defRPr>
       </a:lvl8pPr>
-      <a:lvl9pPr marL="1828800" algn="ctr" rtl="0" fontAlgn="base" latinLnBrk="1">
+      <a:lvl9pPr marL="1828800" algn="ctr" rtl="0" fontAlgn="base" latinLnBrk="0">
         <a:spcBef>
           <a:spcPct val="0"/>
         </a:spcBef>
@@ -1375,7 +1375,7 @@
       </a:lvl9pPr>
     </p:titleStyle>
     <p:bodyStyle>
-      <a:lvl1pPr marL="342900" indent="-342900" algn="l" rtl="0" eaLnBrk="0" fontAlgn="base" latinLnBrk="1" hangingPunct="0">
+      <a:lvl1pPr marL="342900" indent="-342900" algn="l" rtl="0" eaLnBrk="0" fontAlgn="base" latinLnBrk="0" hangingPunct="0">
         <a:spcBef>
           <a:spcPct val="20000"/>
         </a:spcBef>
@@ -1393,7 +1393,7 @@
           <a:cs typeface="+mn-cs"/>
         </a:defRPr>
       </a:lvl1pPr>
-      <a:lvl2pPr marL="742950" indent="-285750" algn="l" rtl="0" eaLnBrk="0" fontAlgn="base" latinLnBrk="1" hangingPunct="0">
+      <a:lvl2pPr marL="742950" indent="-285750" algn="l" rtl="0" eaLnBrk="0" fontAlgn="base" latinLnBrk="0" hangingPunct="0">
         <a:spcBef>
           <a:spcPct val="20000"/>
         </a:spcBef>
@@ -1411,7 +1411,7 @@
           <a:cs typeface="+mn-cs"/>
         </a:defRPr>
       </a:lvl2pPr>
-      <a:lvl3pPr marL="1143000" indent="-228600" algn="l" rtl="0" eaLnBrk="0" fontAlgn="base" latinLnBrk="1" hangingPunct="0">
+      <a:lvl3pPr marL="1143000" indent="-228600" algn="l" rtl="0" eaLnBrk="0" fontAlgn="base" latinLnBrk="0" hangingPunct="0">
         <a:spcBef>
           <a:spcPct val="20000"/>
         </a:spcBef>
@@ -1429,7 +1429,7 @@
           <a:cs typeface="+mn-cs"/>
         </a:defRPr>
       </a:lvl3pPr>
-      <a:lvl4pPr marL="1600200" indent="-228600" algn="l" rtl="0" eaLnBrk="0" fontAlgn="base" latinLnBrk="1" hangingPunct="0">
+      <a:lvl4pPr marL="1600200" indent="-228600" algn="l" rtl="0" eaLnBrk="0" fontAlgn="base" latinLnBrk="0" hangingPunct="0">
         <a:spcBef>
           <a:spcPct val="20000"/>
         </a:spcBef>
@@ -1447,7 +1447,7 @@
           <a:cs typeface="+mn-cs"/>
         </a:defRPr>
       </a:lvl4pPr>
-      <a:lvl5pPr marL="2057400" indent="-228600" algn="l" rtl="0" eaLnBrk="0" fontAlgn="base" latinLnBrk="1" hangingPunct="0">
+      <a:lvl5pPr marL="2057400" indent="-228600" algn="l" rtl="0" eaLnBrk="0" fontAlgn="base" latinLnBrk="0" hangingPunct="0">
         <a:spcBef>
           <a:spcPct val="20000"/>
         </a:spcBef>
@@ -1465,7 +1465,7 @@
           <a:cs typeface="+mn-cs"/>
         </a:defRPr>
       </a:lvl5pPr>
-      <a:lvl6pPr marL="2514600" indent="-228600" algn="l" defTabSz="914400" rtl="0" eaLnBrk="1" latinLnBrk="1" hangingPunct="1">
+      <a:lvl6pPr marL="2514600" indent="-228600" algn="l" defTabSz="914400" rtl="0" eaLnBrk="1" latinLnBrk="0" hangingPunct="1">
         <a:spcBef>
           <a:spcPct val="20000"/>
         </a:spcBef>
@@ -1480,7 +1480,7 @@
           <a:cs typeface="+mn-cs"/>
         </a:defRPr>
       </a:lvl6pPr>
-      <a:lvl7pPr marL="2971800" indent="-228600" algn="l" defTabSz="914400" rtl="0" eaLnBrk="1" latinLnBrk="1" hangingPunct="1">
+      <a:lvl7pPr marL="2971800" indent="-228600" algn="l" defTabSz="914400" rtl="0" eaLnBrk="1" latinLnBrk="0" hangingPunct="1">
         <a:spcBef>
           <a:spcPct val="20000"/>
         </a:spcBef>
@@ -1495,7 +1495,7 @@
           <a:cs typeface="+mn-cs"/>
         </a:defRPr>
       </a:lvl7pPr>
-      <a:lvl8pPr marL="3429000" indent="-228600" algn="l" defTabSz="914400" rtl="0" eaLnBrk="1" latinLnBrk="1" hangingPunct="1">
+      <a:lvl8pPr marL="3429000" indent="-228600" algn="l" defTabSz="914400" rtl="0" eaLnBrk="1" latinLnBrk="0" hangingPunct="1">
         <a:spcBef>
           <a:spcPct val="20000"/>
         </a:spcBef>
@@ -1510,7 +1510,7 @@
           <a:cs typeface="+mn-cs"/>
         </a:defRPr>
       </a:lvl8pPr>
-      <a:lvl9pPr marL="3886200" indent="-228600" algn="l" defTabSz="914400" rtl="0" eaLnBrk="1" latinLnBrk="1" hangingPunct="1">
+      <a:lvl9pPr marL="3886200" indent="-228600" algn="l" defTabSz="914400" rtl="0" eaLnBrk="1" latinLnBrk="0" hangingPunct="1">
         <a:spcBef>
           <a:spcPct val="20000"/>
         </a:spcBef>
@@ -1530,7 +1530,7 @@
       <a:defPPr>
         <a:defRPr lang="ko-KR"/>
       </a:defPPr>
-      <a:lvl1pPr marL="0" algn="l" defTabSz="914400" rtl="0" eaLnBrk="1" latinLnBrk="1" hangingPunct="1">
+      <a:lvl1pPr marL="0" algn="l" defTabSz="914400" rtl="0" eaLnBrk="1" latinLnBrk="0" hangingPunct="1">
         <a:defRPr sz="1800" kern="1200">
           <a:solidFill>
             <a:schemeClr val="tx1"/>
@@ -1540,7 +1540,7 @@
           <a:cs typeface="+mn-cs"/>
         </a:defRPr>
       </a:lvl1pPr>
-      <a:lvl2pPr marL="457200" algn="l" defTabSz="914400" rtl="0" eaLnBrk="1" latinLnBrk="1" hangingPunct="1">
+      <a:lvl2pPr marL="457200" algn="l" defTabSz="914400" rtl="0" eaLnBrk="1" latinLnBrk="0" hangingPunct="1">
         <a:defRPr sz="1800" kern="1200">
           <a:solidFill>
             <a:schemeClr val="tx1"/>
@@ -1550,7 +1550,7 @@
           <a:cs typeface="+mn-cs"/>
         </a:defRPr>
       </a:lvl2pPr>
-      <a:lvl3pPr marL="914400" algn="l" defTabSz="914400" rtl="0" eaLnBrk="1" latinLnBrk="1" hangingPunct="1">
+      <a:lvl3pPr marL="914400" algn="l" defTabSz="914400" rtl="0" eaLnBrk="1" latinLnBrk="0" hangingPunct="1">
         <a:defRPr sz="1800" kern="1200">
           <a:solidFill>
             <a:schemeClr val="tx1"/>
@@ -1560,7 +1560,7 @@
           <a:cs typeface="+mn-cs"/>
         </a:defRPr>
       </a:lvl3pPr>
-      <a:lvl4pPr marL="1371600" algn="l" defTabSz="914400" rtl="0" eaLnBrk="1" latinLnBrk="1" hangingPunct="1">
+      <a:lvl4pPr marL="1371600" algn="l" defTabSz="914400" rtl="0" eaLnBrk="1" latinLnBrk="0" hangingPunct="1">
         <a:defRPr sz="1800" kern="1200">
           <a:solidFill>
             <a:schemeClr val="tx1"/>
@@ -1570,7 +1570,7 @@
           <a:cs typeface="+mn-cs"/>
         </a:defRPr>
       </a:lvl4pPr>
-      <a:lvl5pPr marL="1828800" algn="l" defTabSz="914400" rtl="0" eaLnBrk="1" latinLnBrk="1" hangingPunct="1">
+      <a:lvl5pPr marL="1828800" algn="l" defTabSz="914400" rtl="0" eaLnBrk="1" latinLnBrk="0" hangingPunct="1">
         <a:defRPr sz="1800" kern="1200">
           <a:solidFill>
             <a:schemeClr val="tx1"/>
@@ -1580,7 +1580,7 @@
           <a:cs typeface="+mn-cs"/>
         </a:defRPr>
       </a:lvl5pPr>
-      <a:lvl6pPr marL="2286000" algn="l" defTabSz="914400" rtl="0" eaLnBrk="1" latinLnBrk="1" hangingPunct="1">
+      <a:lvl6pPr marL="2286000" algn="l" defTabSz="914400" rtl="0" eaLnBrk="1" latinLnBrk="0" hangingPunct="1">
         <a:defRPr sz="1800" kern="1200">
           <a:solidFill>
             <a:schemeClr val="tx1"/>
@@ -1590,7 +1590,7 @@
           <a:cs typeface="+mn-cs"/>
         </a:defRPr>
       </a:lvl6pPr>
-      <a:lvl7pPr marL="2743200" algn="l" defTabSz="914400" rtl="0" eaLnBrk="1" latinLnBrk="1" hangingPunct="1">
+      <a:lvl7pPr marL="2743200" algn="l" defTabSz="914400" rtl="0" eaLnBrk="1" latinLnBrk="0" hangingPunct="1">
         <a:defRPr sz="1800" kern="1200">
           <a:solidFill>
             <a:schemeClr val="tx1"/>
@@ -1600,7 +1600,7 @@
           <a:cs typeface="+mn-cs"/>
         </a:defRPr>
       </a:lvl7pPr>
-      <a:lvl8pPr marL="3200400" algn="l" defTabSz="914400" rtl="0" eaLnBrk="1" latinLnBrk="1" hangingPunct="1">
+      <a:lvl8pPr marL="3200400" algn="l" defTabSz="914400" rtl="0" eaLnBrk="1" latinLnBrk="0" hangingPunct="1">
         <a:defRPr sz="1800" kern="1200">
           <a:solidFill>
             <a:schemeClr val="tx1"/>
@@ -1610,7 +1610,7 @@
           <a:cs typeface="+mn-cs"/>
         </a:defRPr>
       </a:lvl8pPr>
-      <a:lvl9pPr marL="3657600" algn="l" defTabSz="914400" rtl="0" eaLnBrk="1" latinLnBrk="1" hangingPunct="1">
+      <a:lvl9pPr marL="3657600" algn="l" defTabSz="914400" rtl="0" eaLnBrk="1" latinLnBrk="0" hangingPunct="1">
         <a:defRPr sz="1800" kern="1200">
           <a:solidFill>
             <a:schemeClr val="tx1"/>
@@ -1714,11 +1714,6 @@
               </a:rPr>
               <a:t>- 1 -</a:t>
             </a:r>
-            <a:endParaRPr lang="ko-KR" altLang="en-US" dirty="0">
-              <a:solidFill>
-                <a:prstClr val="black"/>
-              </a:solidFill>
-            </a:endParaRPr>
           </a:p>
         </p:txBody>
       </p:sp>
@@ -2074,6 +2069,48 @@
               <a:t>15. 다이어그램 선택</a:t>
             </a:r>
           </a:p>
+          <a:p>
+            <a:pPr lvl="1" marL="355600" indent="0">
+              <a:spcBef>
+                <a:spcPts val="300"/>
+              </a:spcBef>
+              <a:spcAft>
+                <a:spcPts val="300"/>
+              </a:spcAft>
+              <a:buNone/>
+            </a:pPr>
+            <a:r>
+              <a:rPr sz="1600" b="0">
+                <a:solidFill>
+                  <a:srgbClr val="000000"/>
+                </a:solidFill>
+                <a:latin typeface="맑은 고딕"/>
+                <a:ea typeface="맑은 고딕"/>
+              </a:rPr>
+              <a:t>16. 변환이 아닌 설계</a:t>
+            </a:r>
+          </a:p>
+          <a:p>
+            <a:pPr lvl="1" marL="355600" indent="0">
+              <a:spcBef>
+                <a:spcPts val="300"/>
+              </a:spcBef>
+              <a:spcAft>
+                <a:spcPts val="300"/>
+              </a:spcAft>
+              <a:buNone/>
+            </a:pPr>
+            <a:r>
+              <a:rPr sz="1600" b="0">
+                <a:solidFill>
+                  <a:srgbClr val="000000"/>
+                </a:solidFill>
+                <a:latin typeface="맑은 고딕"/>
+                <a:ea typeface="맑은 고딕"/>
+              </a:rPr>
+              <a:t>17. 요구에서 테스트로</a:t>
+            </a:r>
+          </a:p>
         </p:txBody>
       </p:sp>
       <p:sp>
@@ -2178,48 +2215,6 @@
             <a:normAutofit/>
           </a:bodyPr>
           <a:lstStyle/>
-          <a:p>
-            <a:pPr lvl="1" marL="355600" indent="0">
-              <a:spcBef>
-                <a:spcPts val="300"/>
-              </a:spcBef>
-              <a:spcAft>
-                <a:spcPts val="300"/>
-              </a:spcAft>
-              <a:buNone/>
-            </a:pPr>
-            <a:r>
-              <a:rPr sz="1600" b="0">
-                <a:solidFill>
-                  <a:srgbClr val="000000"/>
-                </a:solidFill>
-                <a:latin typeface="맑은 고딕"/>
-                <a:ea typeface="맑은 고딕"/>
-              </a:rPr>
-              <a:t>16. 변환이 아닌 설계</a:t>
-            </a:r>
-          </a:p>
-          <a:p>
-            <a:pPr lvl="1" marL="355600" indent="0">
-              <a:spcBef>
-                <a:spcPts val="300"/>
-              </a:spcBef>
-              <a:spcAft>
-                <a:spcPts val="300"/>
-              </a:spcAft>
-              <a:buNone/>
-            </a:pPr>
-            <a:r>
-              <a:rPr sz="1600" b="0">
-                <a:solidFill>
-                  <a:srgbClr val="000000"/>
-                </a:solidFill>
-                <a:latin typeface="맑은 고딕"/>
-                <a:ea typeface="맑은 고딕"/>
-              </a:rPr>
-              <a:t>17. 요구에서 테스트로</a:t>
-            </a:r>
-          </a:p>
           <a:p>
             <a:pPr lvl="1" marL="355600" indent="0">
               <a:spcBef>
@@ -2633,7 +2628,7 @@
                 <a:gridCol w="1087120"/>
                 <a:gridCol w="4859020"/>
               </a:tblGrid>
-              <a:tr h="317500">
+              <a:tr h="288000">
                 <a:tc>
                   <a:txBody>
                     <a:bodyPr/>
@@ -2767,7 +2762,7 @@
                   </a:tcPr>
                 </a:tc>
               </a:tr>
-              <a:tr h="317500">
+              <a:tr h="288000">
                 <a:tc>
                   <a:txBody>
                     <a:bodyPr/>
@@ -2879,7 +2874,7 @@
                   </a:tcPr>
                 </a:tc>
               </a:tr>
-              <a:tr h="317500">
+              <a:tr h="288000">
                 <a:tc>
                   <a:txBody>
                     <a:bodyPr/>
@@ -2991,7 +2986,7 @@
                   </a:tcPr>
                 </a:tc>
               </a:tr>
-              <a:tr h="317500">
+              <a:tr h="288000">
                 <a:tc>
                   <a:txBody>
                     <a:bodyPr/>
@@ -3103,7 +3098,7 @@
                   </a:tcPr>
                 </a:tc>
               </a:tr>
-              <a:tr h="317500">
+              <a:tr h="288000">
                 <a:tc>
                   <a:txBody>
                     <a:bodyPr/>
@@ -3551,7 +3546,7 @@
         </p:nvSpPr>
         <p:spPr>
           <a:xfrm>
-            <a:off x="365760" y="3304055"/>
+            <a:off x="365760" y="3181207"/>
             <a:ext cx="8412480" cy="2146300"/>
           </a:xfrm>
           <a:prstGeom prst="rect">
@@ -3585,7 +3580,17 @@
                 <a:latin typeface="Consolas"/>
                 <a:ea typeface="맑은 고딕"/>
               </a:rPr>
-              <a:t>record</a:t>
+              <a:t>record </a:t>
+            </a:r>
+            <a:r>
+              <a:rPr sz="1000" b="1">
+                <a:solidFill>
+                  <a:srgbClr val="000000"/>
+                </a:solidFill>
+                <a:latin typeface="Consolas"/>
+                <a:ea typeface="맑은 고딕"/>
+              </a:rPr>
+              <a:t>주문항목</a:t>
             </a:r>
             <a:r>
               <a:rPr sz="1000" b="0">
@@ -3595,47 +3600,7 @@
                 <a:latin typeface="Consolas"/>
                 <a:ea typeface="맑은 고딕"/>
               </a:rPr>
-              <a:t> 주문항목(</a:t>
-            </a:r>
-            <a:r>
-              <a:rPr sz="1000" b="0">
-                <a:solidFill>
-                  <a:srgbClr val="000000"/>
-                </a:solidFill>
-                <a:latin typeface="Consolas"/>
-                <a:ea typeface="맑은 고딕"/>
-              </a:rPr>
-              <a:t>String</a:t>
-            </a:r>
-            <a:r>
-              <a:rPr sz="1000" b="0">
-                <a:solidFill>
-                  <a:srgbClr val="000000"/>
-                </a:solidFill>
-                <a:latin typeface="Consolas"/>
-                <a:ea typeface="맑은 고딕"/>
-              </a:rPr>
-              <a:t> 상품, </a:t>
-            </a:r>
-            <a:r>
-              <a:rPr sz="1000" b="0">
-                <a:solidFill>
-                  <a:srgbClr val="000000"/>
-                </a:solidFill>
-                <a:latin typeface="Consolas"/>
-                <a:ea typeface="맑은 고딕"/>
-              </a:rPr>
-              <a:t>int</a:t>
-            </a:r>
-            <a:r>
-              <a:rPr sz="1000" b="0">
-                <a:solidFill>
-                  <a:srgbClr val="000000"/>
-                </a:solidFill>
-                <a:latin typeface="Consolas"/>
-                <a:ea typeface="맑은 고딕"/>
-              </a:rPr>
-              <a:t> 수량) {</a:t>
+              <a:t>(String 상품, int 수량) {</a:t>
             </a:r>
           </a:p>
           <a:p>
@@ -3683,107 +3648,7 @@
                 <a:latin typeface="Consolas"/>
                 <a:ea typeface="맑은 고딕"/>
               </a:rPr>
-              <a:t>        </a:t>
-            </a:r>
-            <a:r>
-              <a:rPr sz="1000" b="0">
-                <a:solidFill>
-                  <a:srgbClr val="000000"/>
-                </a:solidFill>
-                <a:latin typeface="Consolas"/>
-                <a:ea typeface="맑은 고딕"/>
-              </a:rPr>
-              <a:t>if</a:t>
-            </a:r>
-            <a:r>
-              <a:rPr sz="1000" b="0">
-                <a:solidFill>
-                  <a:srgbClr val="000000"/>
-                </a:solidFill>
-                <a:latin typeface="Consolas"/>
-                <a:ea typeface="맑은 고딕"/>
-              </a:rPr>
-              <a:t> (수량 &lt; 1) </a:t>
-            </a:r>
-            <a:r>
-              <a:rPr sz="1000" b="0">
-                <a:solidFill>
-                  <a:srgbClr val="000000"/>
-                </a:solidFill>
-                <a:latin typeface="Consolas"/>
-                <a:ea typeface="맑은 고딕"/>
-              </a:rPr>
-              <a:t>throw</a:t>
-            </a:r>
-            <a:r>
-              <a:rPr sz="1000" b="0">
-                <a:solidFill>
-                  <a:srgbClr val="000000"/>
-                </a:solidFill>
-                <a:latin typeface="Consolas"/>
-                <a:ea typeface="맑은 고딕"/>
-              </a:rPr>
-              <a:t> </a:t>
-            </a:r>
-            <a:r>
-              <a:rPr sz="1000" b="0">
-                <a:solidFill>
-                  <a:srgbClr val="000000"/>
-                </a:solidFill>
-                <a:latin typeface="Consolas"/>
-                <a:ea typeface="맑은 고딕"/>
-              </a:rPr>
-              <a:t>new</a:t>
-            </a:r>
-            <a:r>
-              <a:rPr sz="1000" b="0">
-                <a:solidFill>
-                  <a:srgbClr val="000000"/>
-                </a:solidFill>
-                <a:latin typeface="Consolas"/>
-                <a:ea typeface="맑은 고딕"/>
-              </a:rPr>
-              <a:t> </a:t>
-            </a:r>
-            <a:r>
-              <a:rPr sz="1000" b="0">
-                <a:solidFill>
-                  <a:srgbClr val="000000"/>
-                </a:solidFill>
-                <a:latin typeface="Consolas"/>
-                <a:ea typeface="맑은 고딕"/>
-              </a:rPr>
-              <a:t>IllegalArgumentException</a:t>
-            </a:r>
-            <a:r>
-              <a:rPr sz="1000" b="0">
-                <a:solidFill>
-                  <a:srgbClr val="000000"/>
-                </a:solidFill>
-                <a:latin typeface="Consolas"/>
-                <a:ea typeface="맑은 고딕"/>
-              </a:rPr>
-              <a:t>(</a:t>
-            </a:r>
-            <a:r>
-              <a:rPr sz="1000" b="0">
-                <a:solidFill>
-                  <a:srgbClr val="000000"/>
-                </a:solidFill>
-                <a:latin typeface="Consolas"/>
-                <a:ea typeface="맑은 고딕"/>
-              </a:rPr>
-              <a:t>"수량은 1 이상"</a:t>
-            </a:r>
-            <a:r>
-              <a:rPr sz="1000" b="0">
-                <a:solidFill>
-                  <a:srgbClr val="000000"/>
-                </a:solidFill>
-                <a:latin typeface="Consolas"/>
-                <a:ea typeface="맑은 고딕"/>
-              </a:rPr>
-              <a:t>);</a:t>
+              <a:t>        if (수량 &lt; 1) throw new IllegalArgumentException("수량은 1 이상");</a:t>
             </a:r>
           </a:p>
           <a:p>
@@ -3869,7 +3734,17 @@
                 <a:latin typeface="Consolas"/>
                 <a:ea typeface="맑은 고딕"/>
               </a:rPr>
-              <a:t>record</a:t>
+              <a:t>record </a:t>
+            </a:r>
+            <a:r>
+              <a:rPr sz="1000" b="1">
+                <a:solidFill>
+                  <a:srgbClr val="000000"/>
+                </a:solidFill>
+                <a:latin typeface="Consolas"/>
+                <a:ea typeface="맑은 고딕"/>
+              </a:rPr>
+              <a:t>주문</a:t>
             </a:r>
             <a:r>
               <a:rPr sz="1000" b="0">
@@ -3879,87 +3754,7 @@
                 <a:latin typeface="Consolas"/>
                 <a:ea typeface="맑은 고딕"/>
               </a:rPr>
-              <a:t> 주문(</a:t>
-            </a:r>
-            <a:r>
-              <a:rPr sz="1000" b="0">
-                <a:solidFill>
-                  <a:srgbClr val="000000"/>
-                </a:solidFill>
-                <a:latin typeface="Consolas"/>
-                <a:ea typeface="맑은 고딕"/>
-              </a:rPr>
-              <a:t>String</a:t>
-            </a:r>
-            <a:r>
-              <a:rPr sz="1000" b="0">
-                <a:solidFill>
-                  <a:srgbClr val="000000"/>
-                </a:solidFill>
-                <a:latin typeface="Consolas"/>
-                <a:ea typeface="맑은 고딕"/>
-              </a:rPr>
-              <a:t> 고객, </a:t>
-            </a:r>
-            <a:r>
-              <a:rPr sz="1000" b="0">
-                <a:solidFill>
-                  <a:srgbClr val="000000"/>
-                </a:solidFill>
-                <a:latin typeface="Consolas"/>
-                <a:ea typeface="맑은 고딕"/>
-              </a:rPr>
-              <a:t>java</a:t>
-            </a:r>
-            <a:r>
-              <a:rPr sz="1000" b="0">
-                <a:solidFill>
-                  <a:srgbClr val="000000"/>
-                </a:solidFill>
-                <a:latin typeface="Consolas"/>
-                <a:ea typeface="맑은 고딕"/>
-              </a:rPr>
-              <a:t>.</a:t>
-            </a:r>
-            <a:r>
-              <a:rPr sz="1000" b="0">
-                <a:solidFill>
-                  <a:srgbClr val="000000"/>
-                </a:solidFill>
-                <a:latin typeface="Consolas"/>
-                <a:ea typeface="맑은 고딕"/>
-              </a:rPr>
-              <a:t>util</a:t>
-            </a:r>
-            <a:r>
-              <a:rPr sz="1000" b="0">
-                <a:solidFill>
-                  <a:srgbClr val="000000"/>
-                </a:solidFill>
-                <a:latin typeface="Consolas"/>
-                <a:ea typeface="맑은 고딕"/>
-              </a:rPr>
-              <a:t>.</a:t>
-            </a:r>
-            <a:r>
-              <a:rPr sz="1000" b="0">
-                <a:solidFill>
-                  <a:srgbClr val="000000"/>
-                </a:solidFill>
-                <a:latin typeface="Consolas"/>
-                <a:ea typeface="맑은 고딕"/>
-              </a:rPr>
-              <a:t>List</a:t>
-            </a:r>
-            <a:r>
-              <a:rPr sz="1000" b="0">
-                <a:solidFill>
-                  <a:srgbClr val="000000"/>
-                </a:solidFill>
-                <a:latin typeface="Consolas"/>
-                <a:ea typeface="맑은 고딕"/>
-              </a:rPr>
-              <a:t>&lt;주문항목&gt; 항목들) {</a:t>
+              <a:t>(String 고객, java.util.List&lt;주문항목&gt; 항목들) {</a:t>
             </a:r>
           </a:p>
           <a:p>
@@ -4007,87 +3802,7 @@
                 <a:latin typeface="Consolas"/>
                 <a:ea typeface="맑은 고딕"/>
               </a:rPr>
-              <a:t>        항목들 = </a:t>
-            </a:r>
-            <a:r>
-              <a:rPr sz="1000" b="0">
-                <a:solidFill>
-                  <a:srgbClr val="000000"/>
-                </a:solidFill>
-                <a:latin typeface="Consolas"/>
-                <a:ea typeface="맑은 고딕"/>
-              </a:rPr>
-              <a:t>java</a:t>
-            </a:r>
-            <a:r>
-              <a:rPr sz="1000" b="0">
-                <a:solidFill>
-                  <a:srgbClr val="000000"/>
-                </a:solidFill>
-                <a:latin typeface="Consolas"/>
-                <a:ea typeface="맑은 고딕"/>
-              </a:rPr>
-              <a:t>.</a:t>
-            </a:r>
-            <a:r>
-              <a:rPr sz="1000" b="0">
-                <a:solidFill>
-                  <a:srgbClr val="000000"/>
-                </a:solidFill>
-                <a:latin typeface="Consolas"/>
-                <a:ea typeface="맑은 고딕"/>
-              </a:rPr>
-              <a:t>util</a:t>
-            </a:r>
-            <a:r>
-              <a:rPr sz="1000" b="0">
-                <a:solidFill>
-                  <a:srgbClr val="000000"/>
-                </a:solidFill>
-                <a:latin typeface="Consolas"/>
-                <a:ea typeface="맑은 고딕"/>
-              </a:rPr>
-              <a:t>.</a:t>
-            </a:r>
-            <a:r>
-              <a:rPr sz="1000" b="0">
-                <a:solidFill>
-                  <a:srgbClr val="000000"/>
-                </a:solidFill>
-                <a:latin typeface="Consolas"/>
-                <a:ea typeface="맑은 고딕"/>
-              </a:rPr>
-              <a:t>List</a:t>
-            </a:r>
-            <a:r>
-              <a:rPr sz="1000" b="0">
-                <a:solidFill>
-                  <a:srgbClr val="000000"/>
-                </a:solidFill>
-                <a:latin typeface="Consolas"/>
-                <a:ea typeface="맑은 고딕"/>
-              </a:rPr>
-              <a:t>.</a:t>
-            </a:r>
-            <a:r>
-              <a:rPr sz="1000" b="1">
-                <a:solidFill>
-                  <a:srgbClr val="000000"/>
-                </a:solidFill>
-                <a:latin typeface="Consolas"/>
-                <a:ea typeface="맑은 고딕"/>
-              </a:rPr>
-              <a:t>copyOf</a:t>
-            </a:r>
-            <a:r>
-              <a:rPr sz="1000" b="0">
-                <a:solidFill>
-                  <a:srgbClr val="000000"/>
-                </a:solidFill>
-                <a:latin typeface="Consolas"/>
-                <a:ea typeface="맑은 고딕"/>
-              </a:rPr>
-              <a:t>(항목들);</a:t>
+              <a:t>        항목들 = java.util.List.copyOf(항목들);</a:t>
             </a:r>
           </a:p>
           <a:p>
@@ -4111,127 +3826,7 @@
                 <a:latin typeface="Consolas"/>
                 <a:ea typeface="맑은 고딕"/>
               </a:rPr>
-              <a:t>        </a:t>
-            </a:r>
-            <a:r>
-              <a:rPr sz="1000" b="0">
-                <a:solidFill>
-                  <a:srgbClr val="000000"/>
-                </a:solidFill>
-                <a:latin typeface="Consolas"/>
-                <a:ea typeface="맑은 고딕"/>
-              </a:rPr>
-              <a:t>if</a:t>
-            </a:r>
-            <a:r>
-              <a:rPr sz="1000" b="0">
-                <a:solidFill>
-                  <a:srgbClr val="000000"/>
-                </a:solidFill>
-                <a:latin typeface="Consolas"/>
-                <a:ea typeface="맑은 고딕"/>
-              </a:rPr>
-              <a:t> (항목들.</a:t>
-            </a:r>
-            <a:r>
-              <a:rPr sz="1000" b="0">
-                <a:solidFill>
-                  <a:srgbClr val="000000"/>
-                </a:solidFill>
-                <a:latin typeface="Consolas"/>
-                <a:ea typeface="맑은 고딕"/>
-              </a:rPr>
-              <a:t>isEmpty</a:t>
-            </a:r>
-            <a:r>
-              <a:rPr sz="1000" b="0">
-                <a:solidFill>
-                  <a:srgbClr val="000000"/>
-                </a:solidFill>
-                <a:latin typeface="Consolas"/>
-                <a:ea typeface="맑은 고딕"/>
-              </a:rPr>
-              <a:t>()) </a:t>
-            </a:r>
-            <a:r>
-              <a:rPr sz="1000" b="0">
-                <a:solidFill>
-                  <a:srgbClr val="000000"/>
-                </a:solidFill>
-                <a:latin typeface="Consolas"/>
-                <a:ea typeface="맑은 고딕"/>
-              </a:rPr>
-              <a:t>throw</a:t>
-            </a:r>
-            <a:r>
-              <a:rPr sz="1000" b="0">
-                <a:solidFill>
-                  <a:srgbClr val="000000"/>
-                </a:solidFill>
-                <a:latin typeface="Consolas"/>
-                <a:ea typeface="맑은 고딕"/>
-              </a:rPr>
-              <a:t> </a:t>
-            </a:r>
-            <a:r>
-              <a:rPr sz="1000" b="0">
-                <a:solidFill>
-                  <a:srgbClr val="000000"/>
-                </a:solidFill>
-                <a:latin typeface="Consolas"/>
-                <a:ea typeface="맑은 고딕"/>
-              </a:rPr>
-              <a:t>new</a:t>
-            </a:r>
-            <a:r>
-              <a:rPr sz="1000" b="0">
-                <a:solidFill>
-                  <a:srgbClr val="000000"/>
-                </a:solidFill>
-                <a:latin typeface="Consolas"/>
-                <a:ea typeface="맑은 고딕"/>
-              </a:rPr>
-              <a:t> </a:t>
-            </a:r>
-            <a:r>
-              <a:rPr sz="1000" b="0">
-                <a:solidFill>
-                  <a:srgbClr val="000000"/>
-                </a:solidFill>
-                <a:latin typeface="Consolas"/>
-                <a:ea typeface="맑은 고딕"/>
-              </a:rPr>
-              <a:t>IllegalArgumentException</a:t>
-            </a:r>
-            <a:r>
-              <a:rPr sz="1000" b="0">
-                <a:solidFill>
-                  <a:srgbClr val="000000"/>
-                </a:solidFill>
-                <a:latin typeface="Consolas"/>
-                <a:ea typeface="맑은 고딕"/>
-              </a:rPr>
-              <a:t>(</a:t>
-            </a:r>
-            <a:r>
-              <a:rPr sz="1000" b="0">
-                <a:solidFill>
-                  <a:srgbClr val="000000"/>
-                </a:solidFill>
-                <a:latin typeface="Consolas"/>
-                <a:ea typeface="맑은 고딕"/>
-              </a:rPr>
-              <a:t>"주문 항목은 1개 이상"</a:t>
-            </a:r>
-            <a:r>
-              <a:rPr sz="1000" b="0">
-                <a:solidFill>
-                  <a:srgbClr val="000000"/>
-                </a:solidFill>
-                <a:latin typeface="Consolas"/>
-                <a:ea typeface="맑은 고딕"/>
-              </a:rPr>
-              <a:t>);</a:t>
+              <a:t>        if (항목들.isEmpty()) throw new IllegalArgumentException("주문 항목은 1개 이상");</a:t>
             </a:r>
           </a:p>
           <a:p>
@@ -4390,8 +3985,8 @@
         </p:blipFill>
         <p:spPr>
           <a:xfrm>
-            <a:off x="2436202" y="1842998"/>
-            <a:ext cx="4271596" cy="1351329"/>
+            <a:off x="2630365" y="1842998"/>
+            <a:ext cx="3883269" cy="1228481"/>
           </a:xfrm>
           <a:prstGeom prst="rect">
             <a:avLst/>
@@ -4595,7 +4190,7 @@
         </p:nvSpPr>
         <p:spPr>
           <a:xfrm>
-            <a:off x="365760" y="4009744"/>
+            <a:off x="365760" y="3846110"/>
             <a:ext cx="8412480" cy="825500"/>
           </a:xfrm>
           <a:prstGeom prst="rect">
@@ -4629,7 +4224,17 @@
                 <a:latin typeface="Consolas"/>
                 <a:ea typeface="맑은 고딕"/>
               </a:rPr>
-              <a:t>interface</a:t>
+              <a:t>interface </a:t>
+            </a:r>
+            <a:r>
+              <a:rPr sz="1000" b="1">
+                <a:solidFill>
+                  <a:srgbClr val="000000"/>
+                </a:solidFill>
+                <a:latin typeface="Consolas"/>
+                <a:ea typeface="맑은 고딕"/>
+              </a:rPr>
+              <a:t>주문시스템</a:t>
             </a:r>
             <a:r>
               <a:rPr sz="1000" b="0">
@@ -4639,7 +4244,7 @@
                 <a:latin typeface="Consolas"/>
                 <a:ea typeface="맑은 고딕"/>
               </a:rPr>
-              <a:t> 주문시스템 {</a:t>
+              <a:t> {</a:t>
             </a:r>
           </a:p>
           <a:p>
@@ -4663,7 +4268,17 @@
                 <a:latin typeface="Consolas"/>
                 <a:ea typeface="맑은 고딕"/>
               </a:rPr>
-              <a:t>    </a:t>
+              <a:t>    void </a:t>
+            </a:r>
+            <a:r>
+              <a:rPr sz="1000" b="1">
+                <a:solidFill>
+                  <a:srgbClr val="000000"/>
+                </a:solidFill>
+                <a:latin typeface="Consolas"/>
+                <a:ea typeface="맑은 고딕"/>
+              </a:rPr>
+              <a:t>상품을담는다</a:t>
             </a:r>
             <a:r>
               <a:rPr sz="1000" b="0">
@@ -4673,57 +4288,7 @@
                 <a:latin typeface="Consolas"/>
                 <a:ea typeface="맑은 고딕"/>
               </a:rPr>
-              <a:t>void</a:t>
-            </a:r>
-            <a:r>
-              <a:rPr sz="1000" b="0">
-                <a:solidFill>
-                  <a:srgbClr val="000000"/>
-                </a:solidFill>
-                <a:latin typeface="Consolas"/>
-                <a:ea typeface="맑은 고딕"/>
-              </a:rPr>
-              <a:t> 상품을담는다(</a:t>
-            </a:r>
-            <a:r>
-              <a:rPr sz="1000" b="0">
-                <a:solidFill>
-                  <a:srgbClr val="000000"/>
-                </a:solidFill>
-                <a:latin typeface="Consolas"/>
-                <a:ea typeface="맑은 고딕"/>
-              </a:rPr>
-              <a:t>String</a:t>
-            </a:r>
-            <a:r>
-              <a:rPr sz="1000" b="0">
-                <a:solidFill>
-                  <a:srgbClr val="000000"/>
-                </a:solidFill>
-                <a:latin typeface="Consolas"/>
-                <a:ea typeface="맑은 고딕"/>
-              </a:rPr>
-              <a:t> 상품, </a:t>
-            </a:r>
-            <a:r>
-              <a:rPr sz="1000" b="0">
-                <a:solidFill>
-                  <a:srgbClr val="000000"/>
-                </a:solidFill>
-                <a:latin typeface="Consolas"/>
-                <a:ea typeface="맑은 고딕"/>
-              </a:rPr>
-              <a:t>int</a:t>
-            </a:r>
-            <a:r>
-              <a:rPr sz="1000" b="0">
-                <a:solidFill>
-                  <a:srgbClr val="000000"/>
-                </a:solidFill>
-                <a:latin typeface="Consolas"/>
-                <a:ea typeface="맑은 고딕"/>
-              </a:rPr>
-              <a:t> 수량);</a:t>
+              <a:t>(String 상품, int 수량);</a:t>
             </a:r>
           </a:p>
           <a:p>
@@ -4747,7 +4312,17 @@
                 <a:latin typeface="Consolas"/>
                 <a:ea typeface="맑은 고딕"/>
               </a:rPr>
-              <a:t>    </a:t>
+              <a:t>    void </a:t>
+            </a:r>
+            <a:r>
+              <a:rPr sz="1000" b="1">
+                <a:solidFill>
+                  <a:srgbClr val="000000"/>
+                </a:solidFill>
+                <a:latin typeface="Consolas"/>
+                <a:ea typeface="맑은 고딕"/>
+              </a:rPr>
+              <a:t>주문한다</a:t>
             </a:r>
             <a:r>
               <a:rPr sz="1000" b="0">
@@ -4757,17 +4332,7 @@
                 <a:latin typeface="Consolas"/>
                 <a:ea typeface="맑은 고딕"/>
               </a:rPr>
-              <a:t>void</a:t>
-            </a:r>
-            <a:r>
-              <a:rPr sz="1000" b="0">
-                <a:solidFill>
-                  <a:srgbClr val="000000"/>
-                </a:solidFill>
-                <a:latin typeface="Consolas"/>
-                <a:ea typeface="맑은 고딕"/>
-              </a:rPr>
-              <a:t> 주문한다();</a:t>
+              <a:t>();</a:t>
             </a:r>
           </a:p>
           <a:p>
@@ -4882,8 +4447,8 @@
         </p:blipFill>
         <p:spPr>
           <a:xfrm>
-            <a:off x="3250223" y="2100036"/>
-            <a:ext cx="2643554" cy="1799981"/>
+            <a:off x="3370385" y="2100036"/>
+            <a:ext cx="2403231" cy="1636346"/>
           </a:xfrm>
           <a:prstGeom prst="rect">
             <a:avLst/>
@@ -5087,8 +4652,8 @@
         </p:nvSpPr>
         <p:spPr>
           <a:xfrm>
-            <a:off x="365760" y="4214459"/>
-            <a:ext cx="4114800" cy="1816100"/>
+            <a:off x="365760" y="4813264"/>
+            <a:ext cx="4114800" cy="1341120"/>
           </a:xfrm>
           <a:prstGeom prst="rect">
             <a:avLst/>
@@ -5103,7 +4668,7 @@
           <a:p>
             <a:pPr marL="0" indent="0" algn="l">
               <a:lnSpc>
-                <a:spcPts val="1150"/>
+                <a:spcPts val="960"/>
               </a:lnSpc>
               <a:spcBef>
                 <a:spcPts val="0"/>
@@ -5114,70 +4679,40 @@
               <a:buNone/>
             </a:pPr>
             <a:r>
-              <a:rPr sz="1000" b="0">
+              <a:rPr sz="800" b="0">
                 <a:solidFill>
                   <a:srgbClr val="000000"/>
                 </a:solidFill>
                 <a:latin typeface="Consolas"/>
                 <a:ea typeface="맑은 고딕"/>
               </a:rPr>
-              <a:t>record</a:t>
-            </a:r>
-            <a:r>
-              <a:rPr sz="1000" b="0">
+              <a:t>record </a:t>
+            </a:r>
+            <a:r>
+              <a:rPr sz="800" b="1">
                 <a:solidFill>
                   <a:srgbClr val="000000"/>
                 </a:solidFill>
                 <a:latin typeface="Consolas"/>
                 <a:ea typeface="맑은 고딕"/>
               </a:rPr>
-              <a:t> 상품(</a:t>
-            </a:r>
-            <a:r>
-              <a:rPr sz="1000" b="0">
+              <a:t>상품</a:t>
+            </a:r>
+            <a:r>
+              <a:rPr sz="800" b="0">
                 <a:solidFill>
                   <a:srgbClr val="000000"/>
                 </a:solidFill>
                 <a:latin typeface="Consolas"/>
                 <a:ea typeface="맑은 고딕"/>
               </a:rPr>
-              <a:t>String</a:t>
-            </a:r>
-            <a:r>
-              <a:rPr sz="1000" b="0">
-                <a:solidFill>
-                  <a:srgbClr val="000000"/>
-                </a:solidFill>
-                <a:latin typeface="Consolas"/>
-                <a:ea typeface="맑은 고딕"/>
-              </a:rPr>
-              <a:t> 이름, </a:t>
-            </a:r>
-            <a:r>
-              <a:rPr sz="1000" b="0">
-                <a:solidFill>
-                  <a:srgbClr val="000000"/>
-                </a:solidFill>
-                <a:latin typeface="Consolas"/>
-                <a:ea typeface="맑은 고딕"/>
-              </a:rPr>
-              <a:t>int</a:t>
-            </a:r>
-            <a:r>
-              <a:rPr sz="1000" b="0">
-                <a:solidFill>
-                  <a:srgbClr val="000000"/>
-                </a:solidFill>
-                <a:latin typeface="Consolas"/>
-                <a:ea typeface="맑은 고딕"/>
-              </a:rPr>
-              <a:t> 단가) {}</a:t>
+              <a:t>(String 이름, int 단가) {}</a:t>
             </a:r>
           </a:p>
           <a:p>
             <a:pPr marL="0" indent="0" algn="l">
               <a:lnSpc>
-                <a:spcPts val="1150"/>
+                <a:spcPts val="960"/>
               </a:lnSpc>
               <a:spcBef>
                 <a:spcPts val="0"/>
@@ -5191,7 +4726,7 @@
           <a:p>
             <a:pPr marL="0" indent="0" algn="l">
               <a:lnSpc>
-                <a:spcPts val="1150"/>
+                <a:spcPts val="960"/>
               </a:lnSpc>
               <a:spcBef>
                 <a:spcPts val="0"/>
@@ -5202,50 +4737,40 @@
               <a:buNone/>
             </a:pPr>
             <a:r>
-              <a:rPr sz="1000" b="0">
+              <a:rPr sz="800" b="0">
                 <a:solidFill>
                   <a:srgbClr val="000000"/>
                 </a:solidFill>
                 <a:latin typeface="Consolas"/>
                 <a:ea typeface="맑은 고딕"/>
               </a:rPr>
-              <a:t>record</a:t>
-            </a:r>
-            <a:r>
-              <a:rPr sz="1000" b="0">
+              <a:t>record </a:t>
+            </a:r>
+            <a:r>
+              <a:rPr sz="800" b="1">
                 <a:solidFill>
                   <a:srgbClr val="000000"/>
                 </a:solidFill>
                 <a:latin typeface="Consolas"/>
                 <a:ea typeface="맑은 고딕"/>
               </a:rPr>
-              <a:t> 주문항목(상품 상품, </a:t>
-            </a:r>
-            <a:r>
-              <a:rPr sz="1000" b="0">
+              <a:t>주문항목</a:t>
+            </a:r>
+            <a:r>
+              <a:rPr sz="800" b="0">
                 <a:solidFill>
                   <a:srgbClr val="000000"/>
                 </a:solidFill>
                 <a:latin typeface="Consolas"/>
                 <a:ea typeface="맑은 고딕"/>
               </a:rPr>
-              <a:t>int</a:t>
-            </a:r>
-            <a:r>
-              <a:rPr sz="1000" b="0">
-                <a:solidFill>
-                  <a:srgbClr val="000000"/>
-                </a:solidFill>
-                <a:latin typeface="Consolas"/>
-                <a:ea typeface="맑은 고딕"/>
-              </a:rPr>
-              <a:t> 수량) {</a:t>
+              <a:t>(상품 상품, int 수량) {</a:t>
             </a:r>
           </a:p>
           <a:p>
             <a:pPr marL="0" indent="0" algn="l">
               <a:lnSpc>
-                <a:spcPts val="1150"/>
+                <a:spcPts val="960"/>
               </a:lnSpc>
               <a:spcBef>
                 <a:spcPts val="0"/>
@@ -5256,60 +4781,40 @@
               <a:buNone/>
             </a:pPr>
             <a:r>
-              <a:rPr sz="1000" b="0">
+              <a:rPr sz="800" b="0">
                 <a:solidFill>
                   <a:srgbClr val="000000"/>
                 </a:solidFill>
                 <a:latin typeface="Consolas"/>
                 <a:ea typeface="맑은 고딕"/>
               </a:rPr>
-              <a:t>    </a:t>
-            </a:r>
-            <a:r>
-              <a:rPr sz="1000" b="0">
+              <a:t>    int </a:t>
+            </a:r>
+            <a:r>
+              <a:rPr sz="800" b="1">
                 <a:solidFill>
                   <a:srgbClr val="000000"/>
                 </a:solidFill>
                 <a:latin typeface="Consolas"/>
                 <a:ea typeface="맑은 고딕"/>
               </a:rPr>
-              <a:t>int</a:t>
-            </a:r>
-            <a:r>
-              <a:rPr sz="1000" b="0">
+              <a:t>금액</a:t>
+            </a:r>
+            <a:r>
+              <a:rPr sz="800" b="0">
                 <a:solidFill>
                   <a:srgbClr val="000000"/>
                 </a:solidFill>
                 <a:latin typeface="Consolas"/>
                 <a:ea typeface="맑은 고딕"/>
               </a:rPr>
-              <a:t> 금액() { </a:t>
-            </a:r>
-            <a:r>
-              <a:rPr sz="1000" b="0">
-                <a:solidFill>
-                  <a:srgbClr val="000000"/>
-                </a:solidFill>
-                <a:latin typeface="Consolas"/>
-                <a:ea typeface="맑은 고딕"/>
-              </a:rPr>
-              <a:t>return</a:t>
-            </a:r>
-            <a:r>
-              <a:rPr sz="1000" b="0">
-                <a:solidFill>
-                  <a:srgbClr val="000000"/>
-                </a:solidFill>
-                <a:latin typeface="Consolas"/>
-                <a:ea typeface="맑은 고딕"/>
-              </a:rPr>
-              <a:t> 상품.단가() * 수량; }</a:t>
+              <a:t>() { return 상품.단가() * 수량; }</a:t>
             </a:r>
           </a:p>
           <a:p>
             <a:pPr marL="0" indent="0" algn="l">
               <a:lnSpc>
-                <a:spcPts val="1150"/>
+                <a:spcPts val="960"/>
               </a:lnSpc>
               <a:spcBef>
                 <a:spcPts val="0"/>
@@ -5320,7 +4825,7 @@
               <a:buNone/>
             </a:pPr>
             <a:r>
-              <a:rPr sz="1000" b="0">
+              <a:rPr sz="800" b="0">
                 <a:solidFill>
                   <a:srgbClr val="000000"/>
                 </a:solidFill>
@@ -5333,7 +4838,7 @@
           <a:p>
             <a:pPr marL="0" indent="0" algn="l">
               <a:lnSpc>
-                <a:spcPts val="1150"/>
+                <a:spcPts val="960"/>
               </a:lnSpc>
               <a:spcBef>
                 <a:spcPts val="0"/>
@@ -5347,7 +4852,7 @@
           <a:p>
             <a:pPr marL="0" indent="0" algn="l">
               <a:lnSpc>
-                <a:spcPts val="1150"/>
+                <a:spcPts val="960"/>
               </a:lnSpc>
               <a:spcBef>
                 <a:spcPts val="0"/>
@@ -5358,50 +4863,40 @@
               <a:buNone/>
             </a:pPr>
             <a:r>
-              <a:rPr sz="1000" b="0">
+              <a:rPr sz="800" b="0">
                 <a:solidFill>
                   <a:srgbClr val="000000"/>
                 </a:solidFill>
                 <a:latin typeface="Consolas"/>
                 <a:ea typeface="맑은 고딕"/>
               </a:rPr>
-              <a:t>final</a:t>
-            </a:r>
-            <a:r>
-              <a:rPr sz="1000" b="0">
+              <a:t>final class </a:t>
+            </a:r>
+            <a:r>
+              <a:rPr sz="800" b="1">
                 <a:solidFill>
                   <a:srgbClr val="000000"/>
                 </a:solidFill>
                 <a:latin typeface="Consolas"/>
                 <a:ea typeface="맑은 고딕"/>
               </a:rPr>
-              <a:t> </a:t>
-            </a:r>
-            <a:r>
-              <a:rPr sz="1000" b="0">
+              <a:t>주문</a:t>
+            </a:r>
+            <a:r>
+              <a:rPr sz="800" b="0">
                 <a:solidFill>
                   <a:srgbClr val="000000"/>
                 </a:solidFill>
                 <a:latin typeface="Consolas"/>
                 <a:ea typeface="맑은 고딕"/>
               </a:rPr>
-              <a:t>class</a:t>
-            </a:r>
-            <a:r>
-              <a:rPr sz="1000" b="0">
-                <a:solidFill>
-                  <a:srgbClr val="000000"/>
-                </a:solidFill>
-                <a:latin typeface="Consolas"/>
-                <a:ea typeface="맑은 고딕"/>
-              </a:rPr>
-              <a:t> 주문 {</a:t>
+              <a:t> {</a:t>
             </a:r>
           </a:p>
           <a:p>
             <a:pPr marL="0" indent="0" algn="l">
               <a:lnSpc>
-                <a:spcPts val="1150"/>
+                <a:spcPts val="960"/>
               </a:lnSpc>
               <a:spcBef>
                 <a:spcPts val="0"/>
@@ -5412,200 +4907,20 @@
               <a:buNone/>
             </a:pPr>
             <a:r>
-              <a:rPr sz="1000" b="0">
+              <a:rPr sz="800" b="0">
                 <a:solidFill>
                   <a:srgbClr val="000000"/>
                 </a:solidFill>
                 <a:latin typeface="Consolas"/>
                 <a:ea typeface="맑은 고딕"/>
               </a:rPr>
-              <a:t>    </a:t>
-            </a:r>
-            <a:r>
-              <a:rPr sz="1000" b="0">
-                <a:solidFill>
-                  <a:srgbClr val="000000"/>
-                </a:solidFill>
-                <a:latin typeface="Consolas"/>
-                <a:ea typeface="맑은 고딕"/>
-              </a:rPr>
-              <a:t>private</a:t>
-            </a:r>
-            <a:r>
-              <a:rPr sz="1000" b="0">
-                <a:solidFill>
-                  <a:srgbClr val="000000"/>
-                </a:solidFill>
-                <a:latin typeface="Consolas"/>
-                <a:ea typeface="맑은 고딕"/>
-              </a:rPr>
-              <a:t> </a:t>
-            </a:r>
-            <a:r>
-              <a:rPr sz="1000" b="0">
-                <a:solidFill>
-                  <a:srgbClr val="000000"/>
-                </a:solidFill>
-                <a:latin typeface="Consolas"/>
-                <a:ea typeface="맑은 고딕"/>
-              </a:rPr>
-              <a:t>final</a:t>
-            </a:r>
-            <a:r>
-              <a:rPr sz="1000" b="0">
-                <a:solidFill>
-                  <a:srgbClr val="000000"/>
-                </a:solidFill>
-                <a:latin typeface="Consolas"/>
-                <a:ea typeface="맑은 고딕"/>
-              </a:rPr>
-              <a:t> </a:t>
-            </a:r>
-            <a:r>
-              <a:rPr sz="1000" b="0">
-                <a:solidFill>
-                  <a:srgbClr val="000000"/>
-                </a:solidFill>
-                <a:latin typeface="Consolas"/>
-                <a:ea typeface="맑은 고딕"/>
-              </a:rPr>
-              <a:t>java</a:t>
-            </a:r>
-            <a:r>
-              <a:rPr sz="1000" b="0">
-                <a:solidFill>
-                  <a:srgbClr val="000000"/>
-                </a:solidFill>
-                <a:latin typeface="Consolas"/>
-                <a:ea typeface="맑은 고딕"/>
-              </a:rPr>
-              <a:t>.</a:t>
-            </a:r>
-            <a:r>
-              <a:rPr sz="1000" b="0">
-                <a:solidFill>
-                  <a:srgbClr val="000000"/>
-                </a:solidFill>
-                <a:latin typeface="Consolas"/>
-                <a:ea typeface="맑은 고딕"/>
-              </a:rPr>
-              <a:t>util</a:t>
-            </a:r>
-            <a:r>
-              <a:rPr sz="1000" b="0">
-                <a:solidFill>
-                  <a:srgbClr val="000000"/>
-                </a:solidFill>
-                <a:latin typeface="Consolas"/>
-                <a:ea typeface="맑은 고딕"/>
-              </a:rPr>
-              <a:t>.</a:t>
-            </a:r>
-            <a:r>
-              <a:rPr sz="1000" b="0">
-                <a:solidFill>
-                  <a:srgbClr val="000000"/>
-                </a:solidFill>
-                <a:latin typeface="Consolas"/>
-                <a:ea typeface="맑은 고딕"/>
-              </a:rPr>
-              <a:t>List</a:t>
-            </a:r>
-            <a:r>
-              <a:rPr sz="1000" b="0">
-                <a:solidFill>
-                  <a:srgbClr val="000000"/>
-                </a:solidFill>
-                <a:latin typeface="Consolas"/>
-                <a:ea typeface="맑은 고딕"/>
-              </a:rPr>
-              <a:t>&lt;주문항목&gt; 항목들 = </a:t>
-            </a:r>
-            <a:r>
-              <a:rPr sz="1000" b="0">
-                <a:solidFill>
-                  <a:srgbClr val="000000"/>
-                </a:solidFill>
-                <a:latin typeface="Consolas"/>
-                <a:ea typeface="맑은 고딕"/>
-              </a:rPr>
-              <a:t>new</a:t>
-            </a:r>
-            <a:r>
-              <a:rPr sz="1000" b="0">
-                <a:solidFill>
-                  <a:srgbClr val="000000"/>
-                </a:solidFill>
-                <a:latin typeface="Consolas"/>
-                <a:ea typeface="맑은 고딕"/>
-              </a:rPr>
-              <a:t> </a:t>
-            </a:r>
-            <a:r>
-              <a:rPr sz="1000" b="0">
-                <a:solidFill>
-                  <a:srgbClr val="000000"/>
-                </a:solidFill>
-                <a:latin typeface="Consolas"/>
-                <a:ea typeface="맑은 고딕"/>
-              </a:rPr>
-              <a:t>java</a:t>
-            </a:r>
-            <a:r>
-              <a:rPr sz="1000" b="0">
-                <a:solidFill>
-                  <a:srgbClr val="000000"/>
-                </a:solidFill>
-                <a:latin typeface="Consolas"/>
-                <a:ea typeface="맑은 고딕"/>
-              </a:rPr>
-              <a:t>.</a:t>
-            </a:r>
-            <a:r>
-              <a:rPr sz="1000" b="0">
-                <a:solidFill>
-                  <a:srgbClr val="000000"/>
-                </a:solidFill>
-                <a:latin typeface="Consolas"/>
-                <a:ea typeface="맑은 고딕"/>
-              </a:rPr>
-              <a:t>util</a:t>
-            </a:r>
-            <a:r>
-              <a:rPr sz="1000" b="0">
-                <a:solidFill>
-                  <a:srgbClr val="000000"/>
-                </a:solidFill>
-                <a:latin typeface="Consolas"/>
-                <a:ea typeface="맑은 고딕"/>
-              </a:rPr>
-              <a:t>.</a:t>
-            </a:r>
-            <a:r>
-              <a:rPr sz="1000" b="0">
-                <a:solidFill>
-                  <a:srgbClr val="000000"/>
-                </a:solidFill>
-                <a:latin typeface="Consolas"/>
-                <a:ea typeface="맑은 고딕"/>
-              </a:rPr>
-              <a:t>ArrayList</a:t>
-            </a:r>
-            <a:r>
-              <a:rPr sz="1000" b="0">
-                <a:solidFill>
-                  <a:srgbClr val="000000"/>
-                </a:solidFill>
-                <a:latin typeface="Consolas"/>
-                <a:ea typeface="맑은 고딕"/>
-              </a:rPr>
-              <a:t>&lt;&gt;();</a:t>
+              <a:t>    private final java.util.List&lt;주문항목&gt; 항목들 = new java.util.ArrayList&lt;&gt;();</a:t>
             </a:r>
           </a:p>
           <a:p>
             <a:pPr marL="0" indent="0" algn="l">
               <a:lnSpc>
-                <a:spcPts val="1150"/>
+                <a:spcPts val="960"/>
               </a:lnSpc>
               <a:spcBef>
                 <a:spcPts val="0"/>
@@ -5742,8 +5057,8 @@
         </p:nvSpPr>
         <p:spPr>
           <a:xfrm>
-            <a:off x="4663440" y="4214459"/>
-            <a:ext cx="4114800" cy="1816100"/>
+            <a:off x="4663440" y="4813264"/>
+            <a:ext cx="4114800" cy="1341120"/>
           </a:xfrm>
           <a:prstGeom prst="rect">
             <a:avLst/>
@@ -5758,7 +5073,7 @@
           <a:p>
             <a:pPr marL="0" indent="0" algn="l">
               <a:lnSpc>
-                <a:spcPts val="1150"/>
+                <a:spcPts val="960"/>
               </a:lnSpc>
               <a:spcBef>
                 <a:spcPts val="0"/>
@@ -5769,60 +5084,40 @@
               <a:buNone/>
             </a:pPr>
             <a:r>
-              <a:rPr sz="1000" b="0">
+              <a:rPr sz="800" b="0">
                 <a:solidFill>
                   <a:srgbClr val="000000"/>
                 </a:solidFill>
                 <a:latin typeface="Consolas"/>
                 <a:ea typeface="맑은 고딕"/>
               </a:rPr>
-              <a:t>    </a:t>
-            </a:r>
-            <a:r>
-              <a:rPr sz="1000" b="0">
+              <a:t>    void </a:t>
+            </a:r>
+            <a:r>
+              <a:rPr sz="800" b="1">
                 <a:solidFill>
                   <a:srgbClr val="000000"/>
                 </a:solidFill>
                 <a:latin typeface="Consolas"/>
                 <a:ea typeface="맑은 고딕"/>
               </a:rPr>
-              <a:t>void</a:t>
-            </a:r>
-            <a:r>
-              <a:rPr sz="1000" b="0">
+              <a:t>상품을담는다</a:t>
+            </a:r>
+            <a:r>
+              <a:rPr sz="800" b="0">
                 <a:solidFill>
                   <a:srgbClr val="000000"/>
                 </a:solidFill>
                 <a:latin typeface="Consolas"/>
                 <a:ea typeface="맑은 고딕"/>
               </a:rPr>
-              <a:t> 상품을담는다(상품 상품, </a:t>
-            </a:r>
-            <a:r>
-              <a:rPr sz="1000" b="0">
-                <a:solidFill>
-                  <a:srgbClr val="000000"/>
-                </a:solidFill>
-                <a:latin typeface="Consolas"/>
-                <a:ea typeface="맑은 고딕"/>
-              </a:rPr>
-              <a:t>int</a:t>
-            </a:r>
-            <a:r>
-              <a:rPr sz="1000" b="0">
-                <a:solidFill>
-                  <a:srgbClr val="000000"/>
-                </a:solidFill>
-                <a:latin typeface="Consolas"/>
-                <a:ea typeface="맑은 고딕"/>
-              </a:rPr>
-              <a:t> 수량) {</a:t>
+              <a:t>(상품 상품, int 수량) {</a:t>
             </a:r>
           </a:p>
           <a:p>
             <a:pPr marL="0" indent="0" algn="l">
               <a:lnSpc>
-                <a:spcPts val="1150"/>
+                <a:spcPts val="960"/>
               </a:lnSpc>
               <a:spcBef>
                 <a:spcPts val="0"/>
@@ -5833,60 +5128,20 @@
               <a:buNone/>
             </a:pPr>
             <a:r>
-              <a:rPr sz="1000" b="0">
+              <a:rPr sz="800" b="0">
                 <a:solidFill>
                   <a:srgbClr val="000000"/>
                 </a:solidFill>
                 <a:latin typeface="Consolas"/>
                 <a:ea typeface="맑은 고딕"/>
               </a:rPr>
-              <a:t>        항목들.</a:t>
-            </a:r>
-            <a:r>
-              <a:rPr sz="1000" b="0">
-                <a:solidFill>
-                  <a:srgbClr val="000000"/>
-                </a:solidFill>
-                <a:latin typeface="Consolas"/>
-                <a:ea typeface="맑은 고딕"/>
-              </a:rPr>
-              <a:t>add</a:t>
-            </a:r>
-            <a:r>
-              <a:rPr sz="1000" b="0">
-                <a:solidFill>
-                  <a:srgbClr val="000000"/>
-                </a:solidFill>
-                <a:latin typeface="Consolas"/>
-                <a:ea typeface="맑은 고딕"/>
-              </a:rPr>
-              <a:t>(</a:t>
-            </a:r>
-            <a:r>
-              <a:rPr sz="1000" b="0">
-                <a:solidFill>
-                  <a:srgbClr val="000000"/>
-                </a:solidFill>
-                <a:latin typeface="Consolas"/>
-                <a:ea typeface="맑은 고딕"/>
-              </a:rPr>
-              <a:t>new</a:t>
-            </a:r>
-            <a:r>
-              <a:rPr sz="1000" b="0">
-                <a:solidFill>
-                  <a:srgbClr val="000000"/>
-                </a:solidFill>
-                <a:latin typeface="Consolas"/>
-                <a:ea typeface="맑은 고딕"/>
-              </a:rPr>
-              <a:t> 주문항목(상품, 수량));</a:t>
+              <a:t>        항목들.add(new 주문항목(상품, 수량));</a:t>
             </a:r>
           </a:p>
           <a:p>
             <a:pPr marL="0" indent="0" algn="l">
               <a:lnSpc>
-                <a:spcPts val="1150"/>
+                <a:spcPts val="960"/>
               </a:lnSpc>
               <a:spcBef>
                 <a:spcPts val="0"/>
@@ -5897,7 +5152,7 @@
               <a:buNone/>
             </a:pPr>
             <a:r>
-              <a:rPr sz="1000" b="0">
+              <a:rPr sz="800" b="0">
                 <a:solidFill>
                   <a:srgbClr val="000000"/>
                 </a:solidFill>
@@ -5910,7 +5165,7 @@
           <a:p>
             <a:pPr marL="0" indent="0" algn="l">
               <a:lnSpc>
-                <a:spcPts val="1150"/>
+                <a:spcPts val="960"/>
               </a:lnSpc>
               <a:spcBef>
                 <a:spcPts val="0"/>
@@ -5924,7 +5179,7 @@
           <a:p>
             <a:pPr marL="0" indent="0" algn="l">
               <a:lnSpc>
-                <a:spcPts val="1150"/>
+                <a:spcPts val="960"/>
               </a:lnSpc>
               <a:spcBef>
                 <a:spcPts val="0"/>
@@ -5935,40 +5190,40 @@
               <a:buNone/>
             </a:pPr>
             <a:r>
-              <a:rPr sz="1000" b="0">
+              <a:rPr sz="800" b="0">
                 <a:solidFill>
                   <a:srgbClr val="000000"/>
                 </a:solidFill>
                 <a:latin typeface="Consolas"/>
                 <a:ea typeface="맑은 고딕"/>
               </a:rPr>
-              <a:t>    </a:t>
-            </a:r>
-            <a:r>
-              <a:rPr sz="1000" b="0">
+              <a:t>    int </a:t>
+            </a:r>
+            <a:r>
+              <a:rPr sz="800" b="1">
                 <a:solidFill>
                   <a:srgbClr val="000000"/>
                 </a:solidFill>
                 <a:latin typeface="Consolas"/>
                 <a:ea typeface="맑은 고딕"/>
               </a:rPr>
-              <a:t>int</a:t>
-            </a:r>
-            <a:r>
-              <a:rPr sz="1000" b="0">
+              <a:t>총액을구한다</a:t>
+            </a:r>
+            <a:r>
+              <a:rPr sz="800" b="0">
                 <a:solidFill>
                   <a:srgbClr val="000000"/>
                 </a:solidFill>
                 <a:latin typeface="Consolas"/>
                 <a:ea typeface="맑은 고딕"/>
               </a:rPr>
-              <a:t> 총액을구한다() {</a:t>
+              <a:t>() {</a:t>
             </a:r>
           </a:p>
           <a:p>
             <a:pPr marL="0" indent="0" algn="l">
               <a:lnSpc>
-                <a:spcPts val="1150"/>
+                <a:spcPts val="960"/>
               </a:lnSpc>
               <a:spcBef>
                 <a:spcPts val="0"/>
@@ -5979,40 +5234,20 @@
               <a:buNone/>
             </a:pPr>
             <a:r>
-              <a:rPr sz="1000" b="0">
+              <a:rPr sz="800" b="0">
                 <a:solidFill>
                   <a:srgbClr val="000000"/>
                 </a:solidFill>
                 <a:latin typeface="Consolas"/>
                 <a:ea typeface="맑은 고딕"/>
               </a:rPr>
-              <a:t>        </a:t>
-            </a:r>
-            <a:r>
-              <a:rPr sz="1000" b="0">
-                <a:solidFill>
-                  <a:srgbClr val="000000"/>
-                </a:solidFill>
-                <a:latin typeface="Consolas"/>
-                <a:ea typeface="맑은 고딕"/>
-              </a:rPr>
-              <a:t>int</a:t>
-            </a:r>
-            <a:r>
-              <a:rPr sz="1000" b="0">
-                <a:solidFill>
-                  <a:srgbClr val="000000"/>
-                </a:solidFill>
-                <a:latin typeface="Consolas"/>
-                <a:ea typeface="맑은 고딕"/>
-              </a:rPr>
-              <a:t> 합계 = 0;</a:t>
+              <a:t>        int 합계 = 0;</a:t>
             </a:r>
           </a:p>
           <a:p>
             <a:pPr marL="0" indent="0" algn="l">
               <a:lnSpc>
-                <a:spcPts val="1150"/>
+                <a:spcPts val="960"/>
               </a:lnSpc>
               <a:spcBef>
                 <a:spcPts val="0"/>
@@ -6023,40 +5258,20 @@
               <a:buNone/>
             </a:pPr>
             <a:r>
-              <a:rPr sz="1000" b="0">
+              <a:rPr sz="800" b="0">
                 <a:solidFill>
                   <a:srgbClr val="000000"/>
                 </a:solidFill>
                 <a:latin typeface="Consolas"/>
                 <a:ea typeface="맑은 고딕"/>
               </a:rPr>
-              <a:t>        </a:t>
-            </a:r>
-            <a:r>
-              <a:rPr sz="1000" b="0">
-                <a:solidFill>
-                  <a:srgbClr val="000000"/>
-                </a:solidFill>
-                <a:latin typeface="Consolas"/>
-                <a:ea typeface="맑은 고딕"/>
-              </a:rPr>
-              <a:t>for</a:t>
-            </a:r>
-            <a:r>
-              <a:rPr sz="1000" b="0">
-                <a:solidFill>
-                  <a:srgbClr val="000000"/>
-                </a:solidFill>
-                <a:latin typeface="Consolas"/>
-                <a:ea typeface="맑은 고딕"/>
-              </a:rPr>
-              <a:t> (주문항목 항목 : 항목들) 합계 += 항목.금액();</a:t>
+              <a:t>        for (주문항목 항목 : 항목들) 합계 += 항목.금액();</a:t>
             </a:r>
           </a:p>
           <a:p>
             <a:pPr marL="0" indent="0" algn="l">
               <a:lnSpc>
-                <a:spcPts val="1150"/>
+                <a:spcPts val="960"/>
               </a:lnSpc>
               <a:spcBef>
                 <a:spcPts val="0"/>
@@ -6067,40 +5282,20 @@
               <a:buNone/>
             </a:pPr>
             <a:r>
-              <a:rPr sz="1000" b="0">
+              <a:rPr sz="800" b="0">
                 <a:solidFill>
                   <a:srgbClr val="000000"/>
                 </a:solidFill>
                 <a:latin typeface="Consolas"/>
                 <a:ea typeface="맑은 고딕"/>
               </a:rPr>
-              <a:t>        </a:t>
-            </a:r>
-            <a:r>
-              <a:rPr sz="1000" b="0">
-                <a:solidFill>
-                  <a:srgbClr val="000000"/>
-                </a:solidFill>
-                <a:latin typeface="Consolas"/>
-                <a:ea typeface="맑은 고딕"/>
-              </a:rPr>
-              <a:t>return</a:t>
-            </a:r>
-            <a:r>
-              <a:rPr sz="1000" b="0">
-                <a:solidFill>
-                  <a:srgbClr val="000000"/>
-                </a:solidFill>
-                <a:latin typeface="Consolas"/>
-                <a:ea typeface="맑은 고딕"/>
-              </a:rPr>
-              <a:t> 합계;</a:t>
+              <a:t>        return 합계;</a:t>
             </a:r>
           </a:p>
           <a:p>
             <a:pPr marL="0" indent="0" algn="l">
               <a:lnSpc>
-                <a:spcPts val="1150"/>
+                <a:spcPts val="960"/>
               </a:lnSpc>
               <a:spcBef>
                 <a:spcPts val="0"/>
@@ -6111,7 +5306,7 @@
               <a:buNone/>
             </a:pPr>
             <a:r>
-              <a:rPr sz="1000" b="0">
+              <a:rPr sz="800" b="0">
                 <a:solidFill>
                   <a:srgbClr val="000000"/>
                 </a:solidFill>
@@ -6124,7 +5319,7 @@
           <a:p>
             <a:pPr marL="0" indent="0" algn="l">
               <a:lnSpc>
-                <a:spcPts val="1150"/>
+                <a:spcPts val="960"/>
               </a:lnSpc>
               <a:spcBef>
                 <a:spcPts val="0"/>
@@ -6135,7 +5330,7 @@
               <a:buNone/>
             </a:pPr>
             <a:r>
-              <a:rPr sz="1000" b="0">
+              <a:rPr sz="800" b="0">
                 <a:solidFill>
                   <a:srgbClr val="000000"/>
                 </a:solidFill>
@@ -6163,8 +5358,8 @@
         </p:blipFill>
         <p:spPr>
           <a:xfrm>
-            <a:off x="3037449" y="2100036"/>
-            <a:ext cx="3069102" cy="2004695"/>
+            <a:off x="2579077" y="2100036"/>
+            <a:ext cx="3985846" cy="2603500"/>
           </a:xfrm>
           <a:prstGeom prst="rect">
             <a:avLst/>
@@ -6368,7 +5563,7 @@
         </p:nvSpPr>
         <p:spPr>
           <a:xfrm>
-            <a:off x="365760" y="2361080"/>
+            <a:off x="365760" y="2323957"/>
             <a:ext cx="8412480" cy="2476500"/>
           </a:xfrm>
           <a:prstGeom prst="rect">
@@ -6402,7 +5597,17 @@
                 <a:latin typeface="Consolas"/>
                 <a:ea typeface="맑은 고딕"/>
               </a:rPr>
-              <a:t>record</a:t>
+              <a:t>record </a:t>
+            </a:r>
+            <a:r>
+              <a:rPr sz="1000" b="1">
+                <a:solidFill>
+                  <a:srgbClr val="000000"/>
+                </a:solidFill>
+                <a:latin typeface="Consolas"/>
+                <a:ea typeface="맑은 고딕"/>
+              </a:rPr>
+              <a:t>상품</a:t>
             </a:r>
             <a:r>
               <a:rPr sz="1000" b="0">
@@ -6412,47 +5617,7 @@
                 <a:latin typeface="Consolas"/>
                 <a:ea typeface="맑은 고딕"/>
               </a:rPr>
-              <a:t> 상품(</a:t>
-            </a:r>
-            <a:r>
-              <a:rPr sz="1000" b="0">
-                <a:solidFill>
-                  <a:srgbClr val="000000"/>
-                </a:solidFill>
-                <a:latin typeface="Consolas"/>
-                <a:ea typeface="맑은 고딕"/>
-              </a:rPr>
-              <a:t>String</a:t>
-            </a:r>
-            <a:r>
-              <a:rPr sz="1000" b="0">
-                <a:solidFill>
-                  <a:srgbClr val="000000"/>
-                </a:solidFill>
-                <a:latin typeface="Consolas"/>
-                <a:ea typeface="맑은 고딕"/>
-              </a:rPr>
-              <a:t> 이름, </a:t>
-            </a:r>
-            <a:r>
-              <a:rPr sz="1000" b="0">
-                <a:solidFill>
-                  <a:srgbClr val="000000"/>
-                </a:solidFill>
-                <a:latin typeface="Consolas"/>
-                <a:ea typeface="맑은 고딕"/>
-              </a:rPr>
-              <a:t>int</a:t>
-            </a:r>
-            <a:r>
-              <a:rPr sz="1000" b="0">
-                <a:solidFill>
-                  <a:srgbClr val="000000"/>
-                </a:solidFill>
-                <a:latin typeface="Consolas"/>
-                <a:ea typeface="맑은 고딕"/>
-              </a:rPr>
-              <a:t> 단가) {}</a:t>
+              <a:t>(String 이름, int 단가) {}</a:t>
             </a:r>
           </a:p>
           <a:p>
@@ -6490,7 +5655,17 @@
                 <a:latin typeface="Consolas"/>
                 <a:ea typeface="맑은 고딕"/>
               </a:rPr>
-              <a:t>record</a:t>
+              <a:t>record </a:t>
+            </a:r>
+            <a:r>
+              <a:rPr sz="1000" b="1">
+                <a:solidFill>
+                  <a:srgbClr val="000000"/>
+                </a:solidFill>
+                <a:latin typeface="Consolas"/>
+                <a:ea typeface="맑은 고딕"/>
+              </a:rPr>
+              <a:t>주문항목</a:t>
             </a:r>
             <a:r>
               <a:rPr sz="1000" b="0">
@@ -6500,27 +5675,7 @@
                 <a:latin typeface="Consolas"/>
                 <a:ea typeface="맑은 고딕"/>
               </a:rPr>
-              <a:t> 주문항목(상품 상품, </a:t>
-            </a:r>
-            <a:r>
-              <a:rPr sz="1000" b="0">
-                <a:solidFill>
-                  <a:srgbClr val="000000"/>
-                </a:solidFill>
-                <a:latin typeface="Consolas"/>
-                <a:ea typeface="맑은 고딕"/>
-              </a:rPr>
-              <a:t>int</a:t>
-            </a:r>
-            <a:r>
-              <a:rPr sz="1000" b="0">
-                <a:solidFill>
-                  <a:srgbClr val="000000"/>
-                </a:solidFill>
-                <a:latin typeface="Consolas"/>
-                <a:ea typeface="맑은 고딕"/>
-              </a:rPr>
-              <a:t> 수량) {</a:t>
+              <a:t>(상품 상품, int 수량) {</a:t>
             </a:r>
           </a:p>
           <a:p>
@@ -6544,7 +5699,17 @@
                 <a:latin typeface="Consolas"/>
                 <a:ea typeface="맑은 고딕"/>
               </a:rPr>
-              <a:t>    </a:t>
+              <a:t>    int </a:t>
+            </a:r>
+            <a:r>
+              <a:rPr sz="1000" b="1">
+                <a:solidFill>
+                  <a:srgbClr val="000000"/>
+                </a:solidFill>
+                <a:latin typeface="Consolas"/>
+                <a:ea typeface="맑은 고딕"/>
+              </a:rPr>
+              <a:t>금액</a:t>
             </a:r>
             <a:r>
               <a:rPr sz="1000" b="0">
@@ -6554,37 +5719,7 @@
                 <a:latin typeface="Consolas"/>
                 <a:ea typeface="맑은 고딕"/>
               </a:rPr>
-              <a:t>int</a:t>
-            </a:r>
-            <a:r>
-              <a:rPr sz="1000" b="0">
-                <a:solidFill>
-                  <a:srgbClr val="000000"/>
-                </a:solidFill>
-                <a:latin typeface="Consolas"/>
-                <a:ea typeface="맑은 고딕"/>
-              </a:rPr>
-              <a:t> 금액() { </a:t>
-            </a:r>
-            <a:r>
-              <a:rPr sz="1000" b="0">
-                <a:solidFill>
-                  <a:srgbClr val="000000"/>
-                </a:solidFill>
-                <a:latin typeface="Consolas"/>
-                <a:ea typeface="맑은 고딕"/>
-              </a:rPr>
-              <a:t>return</a:t>
-            </a:r>
-            <a:r>
-              <a:rPr sz="1000" b="0">
-                <a:solidFill>
-                  <a:srgbClr val="000000"/>
-                </a:solidFill>
-                <a:latin typeface="Consolas"/>
-                <a:ea typeface="맑은 고딕"/>
-              </a:rPr>
-              <a:t> 상품.단가() * 수량; }</a:t>
+              <a:t>() { return 상품.단가() * 수량; }</a:t>
             </a:r>
           </a:p>
           <a:p>
@@ -6646,7 +5781,17 @@
                 <a:latin typeface="Consolas"/>
                 <a:ea typeface="맑은 고딕"/>
               </a:rPr>
-              <a:t>final</a:t>
+              <a:t>final class </a:t>
+            </a:r>
+            <a:r>
+              <a:rPr sz="1000" b="1">
+                <a:solidFill>
+                  <a:srgbClr val="000000"/>
+                </a:solidFill>
+                <a:latin typeface="Consolas"/>
+                <a:ea typeface="맑은 고딕"/>
+              </a:rPr>
+              <a:t>주문</a:t>
             </a:r>
             <a:r>
               <a:rPr sz="1000" b="0">
@@ -6656,27 +5801,7 @@
                 <a:latin typeface="Consolas"/>
                 <a:ea typeface="맑은 고딕"/>
               </a:rPr>
-              <a:t> </a:t>
-            </a:r>
-            <a:r>
-              <a:rPr sz="1000" b="0">
-                <a:solidFill>
-                  <a:srgbClr val="000000"/>
-                </a:solidFill>
-                <a:latin typeface="Consolas"/>
-                <a:ea typeface="맑은 고딕"/>
-              </a:rPr>
-              <a:t>class</a:t>
-            </a:r>
-            <a:r>
-              <a:rPr sz="1000" b="0">
-                <a:solidFill>
-                  <a:srgbClr val="000000"/>
-                </a:solidFill>
-                <a:latin typeface="Consolas"/>
-                <a:ea typeface="맑은 고딕"/>
-              </a:rPr>
-              <a:t> 주문 {</a:t>
+              <a:t> {</a:t>
             </a:r>
           </a:p>
           <a:p>
@@ -6700,107 +5825,7 @@
                 <a:latin typeface="Consolas"/>
                 <a:ea typeface="맑은 고딕"/>
               </a:rPr>
-              <a:t>    </a:t>
-            </a:r>
-            <a:r>
-              <a:rPr sz="1000" b="0">
-                <a:solidFill>
-                  <a:srgbClr val="000000"/>
-                </a:solidFill>
-                <a:latin typeface="Consolas"/>
-                <a:ea typeface="맑은 고딕"/>
-              </a:rPr>
-              <a:t>private</a:t>
-            </a:r>
-            <a:r>
-              <a:rPr sz="1000" b="0">
-                <a:solidFill>
-                  <a:srgbClr val="000000"/>
-                </a:solidFill>
-                <a:latin typeface="Consolas"/>
-                <a:ea typeface="맑은 고딕"/>
-              </a:rPr>
-              <a:t> </a:t>
-            </a:r>
-            <a:r>
-              <a:rPr sz="1000" b="0">
-                <a:solidFill>
-                  <a:srgbClr val="000000"/>
-                </a:solidFill>
-                <a:latin typeface="Consolas"/>
-                <a:ea typeface="맑은 고딕"/>
-              </a:rPr>
-              <a:t>final</a:t>
-            </a:r>
-            <a:r>
-              <a:rPr sz="1000" b="0">
-                <a:solidFill>
-                  <a:srgbClr val="000000"/>
-                </a:solidFill>
-                <a:latin typeface="Consolas"/>
-                <a:ea typeface="맑은 고딕"/>
-              </a:rPr>
-              <a:t> </a:t>
-            </a:r>
-            <a:r>
-              <a:rPr sz="1000" b="0">
-                <a:solidFill>
-                  <a:srgbClr val="000000"/>
-                </a:solidFill>
-                <a:latin typeface="Consolas"/>
-                <a:ea typeface="맑은 고딕"/>
-              </a:rPr>
-              <a:t>java</a:t>
-            </a:r>
-            <a:r>
-              <a:rPr sz="1000" b="0">
-                <a:solidFill>
-                  <a:srgbClr val="000000"/>
-                </a:solidFill>
-                <a:latin typeface="Consolas"/>
-                <a:ea typeface="맑은 고딕"/>
-              </a:rPr>
-              <a:t>.</a:t>
-            </a:r>
-            <a:r>
-              <a:rPr sz="1000" b="0">
-                <a:solidFill>
-                  <a:srgbClr val="000000"/>
-                </a:solidFill>
-                <a:latin typeface="Consolas"/>
-                <a:ea typeface="맑은 고딕"/>
-              </a:rPr>
-              <a:t>util</a:t>
-            </a:r>
-            <a:r>
-              <a:rPr sz="1000" b="0">
-                <a:solidFill>
-                  <a:srgbClr val="000000"/>
-                </a:solidFill>
-                <a:latin typeface="Consolas"/>
-                <a:ea typeface="맑은 고딕"/>
-              </a:rPr>
-              <a:t>.</a:t>
-            </a:r>
-            <a:r>
-              <a:rPr sz="1000" b="0">
-                <a:solidFill>
-                  <a:srgbClr val="000000"/>
-                </a:solidFill>
-                <a:latin typeface="Consolas"/>
-                <a:ea typeface="맑은 고딕"/>
-              </a:rPr>
-              <a:t>List</a:t>
-            </a:r>
-            <a:r>
-              <a:rPr sz="1000" b="0">
-                <a:solidFill>
-                  <a:srgbClr val="000000"/>
-                </a:solidFill>
-                <a:latin typeface="Consolas"/>
-                <a:ea typeface="맑은 고딕"/>
-              </a:rPr>
-              <a:t>&lt;주문항목&gt; 항목들;</a:t>
+              <a:t>    private final java.util.List&lt;주문항목&gt; 항목들;</a:t>
             </a:r>
           </a:p>
           <a:p>
@@ -6824,7 +5849,17 @@
                 <a:latin typeface="Consolas"/>
                 <a:ea typeface="맑은 고딕"/>
               </a:rPr>
-              <a:t>    주문(</a:t>
+              <a:t>    </a:t>
+            </a:r>
+            <a:r>
+              <a:rPr sz="1000" b="1">
+                <a:solidFill>
+                  <a:srgbClr val="000000"/>
+                </a:solidFill>
+                <a:latin typeface="Consolas"/>
+                <a:ea typeface="맑은 고딕"/>
+              </a:rPr>
+              <a:t>주문</a:t>
             </a:r>
             <a:r>
               <a:rPr sz="1000" b="0">
@@ -6834,77 +5869,7 @@
                 <a:latin typeface="Consolas"/>
                 <a:ea typeface="맑은 고딕"/>
               </a:rPr>
-              <a:t>java</a:t>
-            </a:r>
-            <a:r>
-              <a:rPr sz="1000" b="0">
-                <a:solidFill>
-                  <a:srgbClr val="000000"/>
-                </a:solidFill>
-                <a:latin typeface="Consolas"/>
-                <a:ea typeface="맑은 고딕"/>
-              </a:rPr>
-              <a:t>.</a:t>
-            </a:r>
-            <a:r>
-              <a:rPr sz="1000" b="0">
-                <a:solidFill>
-                  <a:srgbClr val="000000"/>
-                </a:solidFill>
-                <a:latin typeface="Consolas"/>
-                <a:ea typeface="맑은 고딕"/>
-              </a:rPr>
-              <a:t>util</a:t>
-            </a:r>
-            <a:r>
-              <a:rPr sz="1000" b="0">
-                <a:solidFill>
-                  <a:srgbClr val="000000"/>
-                </a:solidFill>
-                <a:latin typeface="Consolas"/>
-                <a:ea typeface="맑은 고딕"/>
-              </a:rPr>
-              <a:t>.</a:t>
-            </a:r>
-            <a:r>
-              <a:rPr sz="1000" b="0">
-                <a:solidFill>
-                  <a:srgbClr val="000000"/>
-                </a:solidFill>
-                <a:latin typeface="Consolas"/>
-                <a:ea typeface="맑은 고딕"/>
-              </a:rPr>
-              <a:t>List</a:t>
-            </a:r>
-            <a:r>
-              <a:rPr sz="1000" b="0">
-                <a:solidFill>
-                  <a:srgbClr val="000000"/>
-                </a:solidFill>
-                <a:latin typeface="Consolas"/>
-                <a:ea typeface="맑은 고딕"/>
-              </a:rPr>
-              <a:t>&lt;주문항목&gt; 항목들) { </a:t>
-            </a:r>
-            <a:r>
-              <a:rPr sz="1000" b="0">
-                <a:solidFill>
-                  <a:srgbClr val="000000"/>
-                </a:solidFill>
-                <a:latin typeface="Consolas"/>
-                <a:ea typeface="맑은 고딕"/>
-              </a:rPr>
-              <a:t>this</a:t>
-            </a:r>
-            <a:r>
-              <a:rPr sz="1000" b="0">
-                <a:solidFill>
-                  <a:srgbClr val="000000"/>
-                </a:solidFill>
-                <a:latin typeface="Consolas"/>
-                <a:ea typeface="맑은 고딕"/>
-              </a:rPr>
-              <a:t>.항목들 = 항목들; }</a:t>
+              <a:t>(java.util.List&lt;주문항목&gt; 항목들) { this.항목들 = 항목들; }</a:t>
             </a:r>
           </a:p>
           <a:p>
@@ -6942,7 +5907,17 @@
                 <a:latin typeface="Consolas"/>
                 <a:ea typeface="맑은 고딕"/>
               </a:rPr>
-              <a:t>    </a:t>
+              <a:t>    int </a:t>
+            </a:r>
+            <a:r>
+              <a:rPr sz="1000" b="1">
+                <a:solidFill>
+                  <a:srgbClr val="000000"/>
+                </a:solidFill>
+                <a:latin typeface="Consolas"/>
+                <a:ea typeface="맑은 고딕"/>
+              </a:rPr>
+              <a:t>총액을구한다</a:t>
             </a:r>
             <a:r>
               <a:rPr sz="1000" b="0">
@@ -6952,17 +5927,7 @@
                 <a:latin typeface="Consolas"/>
                 <a:ea typeface="맑은 고딕"/>
               </a:rPr>
-              <a:t>int</a:t>
-            </a:r>
-            <a:r>
-              <a:rPr sz="1000" b="0">
-                <a:solidFill>
-                  <a:srgbClr val="000000"/>
-                </a:solidFill>
-                <a:latin typeface="Consolas"/>
-                <a:ea typeface="맑은 고딕"/>
-              </a:rPr>
-              <a:t> 총액을구한다() {</a:t>
+              <a:t>() {</a:t>
             </a:r>
           </a:p>
           <a:p>
@@ -6986,87 +5951,7 @@
                 <a:latin typeface="Consolas"/>
                 <a:ea typeface="맑은 고딕"/>
               </a:rPr>
-              <a:t>        </a:t>
-            </a:r>
-            <a:r>
-              <a:rPr sz="1000" b="0">
-                <a:solidFill>
-                  <a:srgbClr val="000000"/>
-                </a:solidFill>
-                <a:latin typeface="Consolas"/>
-                <a:ea typeface="맑은 고딕"/>
-              </a:rPr>
-              <a:t>return</a:t>
-            </a:r>
-            <a:r>
-              <a:rPr sz="1000" b="0">
-                <a:solidFill>
-                  <a:srgbClr val="000000"/>
-                </a:solidFill>
-                <a:latin typeface="Consolas"/>
-                <a:ea typeface="맑은 고딕"/>
-              </a:rPr>
-              <a:t> 항목들.</a:t>
-            </a:r>
-            <a:r>
-              <a:rPr sz="1000" b="0">
-                <a:solidFill>
-                  <a:srgbClr val="000000"/>
-                </a:solidFill>
-                <a:latin typeface="Consolas"/>
-                <a:ea typeface="맑은 고딕"/>
-              </a:rPr>
-              <a:t>stream</a:t>
-            </a:r>
-            <a:r>
-              <a:rPr sz="1000" b="0">
-                <a:solidFill>
-                  <a:srgbClr val="000000"/>
-                </a:solidFill>
-                <a:latin typeface="Consolas"/>
-                <a:ea typeface="맑은 고딕"/>
-              </a:rPr>
-              <a:t>().</a:t>
-            </a:r>
-            <a:r>
-              <a:rPr sz="1000" b="0">
-                <a:solidFill>
-                  <a:srgbClr val="000000"/>
-                </a:solidFill>
-                <a:latin typeface="Consolas"/>
-                <a:ea typeface="맑은 고딕"/>
-              </a:rPr>
-              <a:t>mapToInt</a:t>
-            </a:r>
-            <a:r>
-              <a:rPr sz="1000" b="0">
-                <a:solidFill>
-                  <a:srgbClr val="000000"/>
-                </a:solidFill>
-                <a:latin typeface="Consolas"/>
-                <a:ea typeface="맑은 고딕"/>
-              </a:rPr>
-              <a:t>(주문항목::금액).</a:t>
-            </a:r>
-            <a:r>
-              <a:rPr sz="1000" b="0">
-                <a:solidFill>
-                  <a:srgbClr val="000000"/>
-                </a:solidFill>
-                <a:latin typeface="Consolas"/>
-                <a:ea typeface="맑은 고딕"/>
-              </a:rPr>
-              <a:t>sum</a:t>
-            </a:r>
-            <a:r>
-              <a:rPr sz="1000" b="0">
-                <a:solidFill>
-                  <a:srgbClr val="000000"/>
-                </a:solidFill>
-                <a:latin typeface="Consolas"/>
-                <a:ea typeface="맑은 고딕"/>
-              </a:rPr>
-              <a:t>();</a:t>
+              <a:t>        return 항목들.stream().mapToInt(주문항목::금액).sum();</a:t>
             </a:r>
           </a:p>
           <a:p>
@@ -7215,8 +6100,8 @@
         </p:blipFill>
         <p:spPr>
           <a:xfrm>
-            <a:off x="687265" y="1842998"/>
-            <a:ext cx="7769469" cy="408354"/>
+            <a:off x="1040423" y="1842998"/>
+            <a:ext cx="7063154" cy="371231"/>
           </a:xfrm>
           <a:prstGeom prst="rect">
             <a:avLst/>
@@ -7420,7 +6305,7 @@
         </p:nvSpPr>
         <p:spPr>
           <a:xfrm>
-            <a:off x="365760" y="3456317"/>
+            <a:off x="365760" y="3342994"/>
             <a:ext cx="8412480" cy="2641600"/>
           </a:xfrm>
           <a:prstGeom prst="rect">
@@ -7454,7 +6339,17 @@
                 <a:latin typeface="Consolas"/>
                 <a:ea typeface="맑은 고딕"/>
               </a:rPr>
-              <a:t>enum</a:t>
+              <a:t>enum </a:t>
+            </a:r>
+            <a:r>
+              <a:rPr sz="1000" b="1">
+                <a:solidFill>
+                  <a:srgbClr val="000000"/>
+                </a:solidFill>
+                <a:latin typeface="Consolas"/>
+                <a:ea typeface="맑은 고딕"/>
+              </a:rPr>
+              <a:t>주문상태</a:t>
             </a:r>
             <a:r>
               <a:rPr sz="1000" b="0">
@@ -7464,7 +6359,7 @@
                 <a:latin typeface="Consolas"/>
                 <a:ea typeface="맑은 고딕"/>
               </a:rPr>
-              <a:t> 주문상태 { 주문됨, 결제됨, 배송됨, 취소됨 }</a:t>
+              <a:t> { 주문됨, 결제됨, 배송됨, 취소됨 }</a:t>
             </a:r>
           </a:p>
           <a:p>
@@ -7502,7 +6397,17 @@
                 <a:latin typeface="Consolas"/>
                 <a:ea typeface="맑은 고딕"/>
               </a:rPr>
-              <a:t>final</a:t>
+              <a:t>final class </a:t>
+            </a:r>
+            <a:r>
+              <a:rPr sz="1000" b="1">
+                <a:solidFill>
+                  <a:srgbClr val="000000"/>
+                </a:solidFill>
+                <a:latin typeface="Consolas"/>
+                <a:ea typeface="맑은 고딕"/>
+              </a:rPr>
+              <a:t>주문</a:t>
             </a:r>
             <a:r>
               <a:rPr sz="1000" b="0">
@@ -7512,27 +6417,7 @@
                 <a:latin typeface="Consolas"/>
                 <a:ea typeface="맑은 고딕"/>
               </a:rPr>
-              <a:t> </a:t>
-            </a:r>
-            <a:r>
-              <a:rPr sz="1000" b="0">
-                <a:solidFill>
-                  <a:srgbClr val="000000"/>
-                </a:solidFill>
-                <a:latin typeface="Consolas"/>
-                <a:ea typeface="맑은 고딕"/>
-              </a:rPr>
-              <a:t>class</a:t>
-            </a:r>
-            <a:r>
-              <a:rPr sz="1000" b="0">
-                <a:solidFill>
-                  <a:srgbClr val="000000"/>
-                </a:solidFill>
-                <a:latin typeface="Consolas"/>
-                <a:ea typeface="맑은 고딕"/>
-              </a:rPr>
-              <a:t> 주문 {</a:t>
+              <a:t> {</a:t>
             </a:r>
           </a:p>
           <a:p>
@@ -7556,27 +6441,7 @@
                 <a:latin typeface="Consolas"/>
                 <a:ea typeface="맑은 고딕"/>
               </a:rPr>
-              <a:t>    </a:t>
-            </a:r>
-            <a:r>
-              <a:rPr sz="1000" b="0">
-                <a:solidFill>
-                  <a:srgbClr val="000000"/>
-                </a:solidFill>
-                <a:latin typeface="Consolas"/>
-                <a:ea typeface="맑은 고딕"/>
-              </a:rPr>
-              <a:t>private</a:t>
-            </a:r>
-            <a:r>
-              <a:rPr sz="1000" b="0">
-                <a:solidFill>
-                  <a:srgbClr val="000000"/>
-                </a:solidFill>
-                <a:latin typeface="Consolas"/>
-                <a:ea typeface="맑은 고딕"/>
-              </a:rPr>
-              <a:t> 주문상태 상태 = 주문상태.주문됨;</a:t>
+              <a:t>    private 주문상태 상태 = 주문상태.주문됨;</a:t>
             </a:r>
           </a:p>
           <a:p>
@@ -7614,7 +6479,17 @@
                 <a:latin typeface="Consolas"/>
                 <a:ea typeface="맑은 고딕"/>
               </a:rPr>
-              <a:t>    </a:t>
+              <a:t>    void </a:t>
+            </a:r>
+            <a:r>
+              <a:rPr sz="1000" b="1">
+                <a:solidFill>
+                  <a:srgbClr val="000000"/>
+                </a:solidFill>
+                <a:latin typeface="Consolas"/>
+                <a:ea typeface="맑은 고딕"/>
+              </a:rPr>
+              <a:t>결제한다</a:t>
             </a:r>
             <a:r>
               <a:rPr sz="1000" b="0">
@@ -7624,17 +6499,7 @@
                 <a:latin typeface="Consolas"/>
                 <a:ea typeface="맑은 고딕"/>
               </a:rPr>
-              <a:t>void</a:t>
-            </a:r>
-            <a:r>
-              <a:rPr sz="1000" b="0">
-                <a:solidFill>
-                  <a:srgbClr val="000000"/>
-                </a:solidFill>
-                <a:latin typeface="Consolas"/>
-                <a:ea typeface="맑은 고딕"/>
-              </a:rPr>
-              <a:t> 결제한다() { 전이(주문상태.결제됨, 주문상태.주문됨); }</a:t>
+              <a:t>() { 전이(주문상태.결제됨, 주문상태.주문됨); }</a:t>
             </a:r>
           </a:p>
           <a:p>
@@ -7658,7 +6523,17 @@
                 <a:latin typeface="Consolas"/>
                 <a:ea typeface="맑은 고딕"/>
               </a:rPr>
-              <a:t>    </a:t>
+              <a:t>    void </a:t>
+            </a:r>
+            <a:r>
+              <a:rPr sz="1000" b="1">
+                <a:solidFill>
+                  <a:srgbClr val="000000"/>
+                </a:solidFill>
+                <a:latin typeface="Consolas"/>
+                <a:ea typeface="맑은 고딕"/>
+              </a:rPr>
+              <a:t>배송한다</a:t>
             </a:r>
             <a:r>
               <a:rPr sz="1000" b="0">
@@ -7668,17 +6543,7 @@
                 <a:latin typeface="Consolas"/>
                 <a:ea typeface="맑은 고딕"/>
               </a:rPr>
-              <a:t>void</a:t>
-            </a:r>
-            <a:r>
-              <a:rPr sz="1000" b="0">
-                <a:solidFill>
-                  <a:srgbClr val="000000"/>
-                </a:solidFill>
-                <a:latin typeface="Consolas"/>
-                <a:ea typeface="맑은 고딕"/>
-              </a:rPr>
-              <a:t> 배송한다() { 전이(주문상태.배송됨, 주문상태.결제됨); }</a:t>
+              <a:t>() { 전이(주문상태.배송됨, 주문상태.결제됨); }</a:t>
             </a:r>
           </a:p>
           <a:p>
@@ -7702,7 +6567,17 @@
                 <a:latin typeface="Consolas"/>
                 <a:ea typeface="맑은 고딕"/>
               </a:rPr>
-              <a:t>    </a:t>
+              <a:t>    void </a:t>
+            </a:r>
+            <a:r>
+              <a:rPr sz="1000" b="1">
+                <a:solidFill>
+                  <a:srgbClr val="000000"/>
+                </a:solidFill>
+                <a:latin typeface="Consolas"/>
+                <a:ea typeface="맑은 고딕"/>
+              </a:rPr>
+              <a:t>취소한다</a:t>
             </a:r>
             <a:r>
               <a:rPr sz="1000" b="0">
@@ -7712,17 +6587,7 @@
                 <a:latin typeface="Consolas"/>
                 <a:ea typeface="맑은 고딕"/>
               </a:rPr>
-              <a:t>void</a:t>
-            </a:r>
-            <a:r>
-              <a:rPr sz="1000" b="0">
-                <a:solidFill>
-                  <a:srgbClr val="000000"/>
-                </a:solidFill>
-                <a:latin typeface="Consolas"/>
-                <a:ea typeface="맑은 고딕"/>
-              </a:rPr>
-              <a:t> 취소한다() { 전이(주문상태.취소됨, 주문상태.주문됨, 주문상태.결제됨); }</a:t>
+              <a:t>() { 전이(주문상태.취소됨, 주문상태.주문됨, 주문상태.결제됨); }</a:t>
             </a:r>
           </a:p>
           <a:p>
@@ -7760,7 +6625,17 @@
                 <a:latin typeface="Consolas"/>
                 <a:ea typeface="맑은 고딕"/>
               </a:rPr>
-              <a:t>    </a:t>
+              <a:t>    private void </a:t>
+            </a:r>
+            <a:r>
+              <a:rPr sz="1000" b="1">
+                <a:solidFill>
+                  <a:srgbClr val="000000"/>
+                </a:solidFill>
+                <a:latin typeface="Consolas"/>
+                <a:ea typeface="맑은 고딕"/>
+              </a:rPr>
+              <a:t>전이</a:t>
             </a:r>
             <a:r>
               <a:rPr sz="1000" b="0">
@@ -7770,37 +6645,7 @@
                 <a:latin typeface="Consolas"/>
                 <a:ea typeface="맑은 고딕"/>
               </a:rPr>
-              <a:t>private</a:t>
-            </a:r>
-            <a:r>
-              <a:rPr sz="1000" b="0">
-                <a:solidFill>
-                  <a:srgbClr val="000000"/>
-                </a:solidFill>
-                <a:latin typeface="Consolas"/>
-                <a:ea typeface="맑은 고딕"/>
-              </a:rPr>
-              <a:t> </a:t>
-            </a:r>
-            <a:r>
-              <a:rPr sz="1000" b="0">
-                <a:solidFill>
-                  <a:srgbClr val="000000"/>
-                </a:solidFill>
-                <a:latin typeface="Consolas"/>
-                <a:ea typeface="맑은 고딕"/>
-              </a:rPr>
-              <a:t>void</a:t>
-            </a:r>
-            <a:r>
-              <a:rPr sz="1000" b="0">
-                <a:solidFill>
-                  <a:srgbClr val="000000"/>
-                </a:solidFill>
-                <a:latin typeface="Consolas"/>
-                <a:ea typeface="맑은 고딕"/>
-              </a:rPr>
-              <a:t> 전이(주문상태 다음, 주문상태... 출발) {</a:t>
+              <a:t>(주문상태 다음, 주문상태... 출발) {</a:t>
             </a:r>
           </a:p>
           <a:p>
@@ -7824,127 +6669,7 @@
                 <a:latin typeface="Consolas"/>
                 <a:ea typeface="맑은 고딕"/>
               </a:rPr>
-              <a:t>        </a:t>
-            </a:r>
-            <a:r>
-              <a:rPr sz="1000" b="0">
-                <a:solidFill>
-                  <a:srgbClr val="000000"/>
-                </a:solidFill>
-                <a:latin typeface="Consolas"/>
-                <a:ea typeface="맑은 고딕"/>
-              </a:rPr>
-              <a:t>if</a:t>
-            </a:r>
-            <a:r>
-              <a:rPr sz="1000" b="0">
-                <a:solidFill>
-                  <a:srgbClr val="000000"/>
-                </a:solidFill>
-                <a:latin typeface="Consolas"/>
-                <a:ea typeface="맑은 고딕"/>
-              </a:rPr>
-              <a:t> (!</a:t>
-            </a:r>
-            <a:r>
-              <a:rPr sz="1000" b="0">
-                <a:solidFill>
-                  <a:srgbClr val="000000"/>
-                </a:solidFill>
-                <a:latin typeface="Consolas"/>
-                <a:ea typeface="맑은 고딕"/>
-              </a:rPr>
-              <a:t>java</a:t>
-            </a:r>
-            <a:r>
-              <a:rPr sz="1000" b="0">
-                <a:solidFill>
-                  <a:srgbClr val="000000"/>
-                </a:solidFill>
-                <a:latin typeface="Consolas"/>
-                <a:ea typeface="맑은 고딕"/>
-              </a:rPr>
-              <a:t>.</a:t>
-            </a:r>
-            <a:r>
-              <a:rPr sz="1000" b="0">
-                <a:solidFill>
-                  <a:srgbClr val="000000"/>
-                </a:solidFill>
-                <a:latin typeface="Consolas"/>
-                <a:ea typeface="맑은 고딕"/>
-              </a:rPr>
-              <a:t>util</a:t>
-            </a:r>
-            <a:r>
-              <a:rPr sz="1000" b="0">
-                <a:solidFill>
-                  <a:srgbClr val="000000"/>
-                </a:solidFill>
-                <a:latin typeface="Consolas"/>
-                <a:ea typeface="맑은 고딕"/>
-              </a:rPr>
-              <a:t>.</a:t>
-            </a:r>
-            <a:r>
-              <a:rPr sz="1000" b="0">
-                <a:solidFill>
-                  <a:srgbClr val="000000"/>
-                </a:solidFill>
-                <a:latin typeface="Consolas"/>
-                <a:ea typeface="맑은 고딕"/>
-              </a:rPr>
-              <a:t>List</a:t>
-            </a:r>
-            <a:r>
-              <a:rPr sz="1000" b="0">
-                <a:solidFill>
-                  <a:srgbClr val="000000"/>
-                </a:solidFill>
-                <a:latin typeface="Consolas"/>
-                <a:ea typeface="맑은 고딕"/>
-              </a:rPr>
-              <a:t>.</a:t>
-            </a:r>
-            <a:r>
-              <a:rPr sz="1000" b="1">
-                <a:solidFill>
-                  <a:srgbClr val="000000"/>
-                </a:solidFill>
-                <a:latin typeface="Consolas"/>
-                <a:ea typeface="맑은 고딕"/>
-              </a:rPr>
-              <a:t>of</a:t>
-            </a:r>
-            <a:r>
-              <a:rPr sz="1000" b="0">
-                <a:solidFill>
-                  <a:srgbClr val="000000"/>
-                </a:solidFill>
-                <a:latin typeface="Consolas"/>
-                <a:ea typeface="맑은 고딕"/>
-              </a:rPr>
-              <a:t>(출발).</a:t>
-            </a:r>
-            <a:r>
-              <a:rPr sz="1000" b="0">
-                <a:solidFill>
-                  <a:srgbClr val="000000"/>
-                </a:solidFill>
-                <a:latin typeface="Consolas"/>
-                <a:ea typeface="맑은 고딕"/>
-              </a:rPr>
-              <a:t>contains</a:t>
-            </a:r>
-            <a:r>
-              <a:rPr sz="1000" b="0">
-                <a:solidFill>
-                  <a:srgbClr val="000000"/>
-                </a:solidFill>
-                <a:latin typeface="Consolas"/>
-                <a:ea typeface="맑은 고딕"/>
-              </a:rPr>
-              <a:t>(상태))</a:t>
+              <a:t>        if (!java.util.List.of(출발).contains(상태))</a:t>
             </a:r>
           </a:p>
           <a:p>
@@ -7968,87 +6693,7 @@
                 <a:latin typeface="Consolas"/>
                 <a:ea typeface="맑은 고딕"/>
               </a:rPr>
-              <a:t>            </a:t>
-            </a:r>
-            <a:r>
-              <a:rPr sz="1000" b="0">
-                <a:solidFill>
-                  <a:srgbClr val="000000"/>
-                </a:solidFill>
-                <a:latin typeface="Consolas"/>
-                <a:ea typeface="맑은 고딕"/>
-              </a:rPr>
-              <a:t>throw</a:t>
-            </a:r>
-            <a:r>
-              <a:rPr sz="1000" b="0">
-                <a:solidFill>
-                  <a:srgbClr val="000000"/>
-                </a:solidFill>
-                <a:latin typeface="Consolas"/>
-                <a:ea typeface="맑은 고딕"/>
-              </a:rPr>
-              <a:t> </a:t>
-            </a:r>
-            <a:r>
-              <a:rPr sz="1000" b="0">
-                <a:solidFill>
-                  <a:srgbClr val="000000"/>
-                </a:solidFill>
-                <a:latin typeface="Consolas"/>
-                <a:ea typeface="맑은 고딕"/>
-              </a:rPr>
-              <a:t>new</a:t>
-            </a:r>
-            <a:r>
-              <a:rPr sz="1000" b="0">
-                <a:solidFill>
-                  <a:srgbClr val="000000"/>
-                </a:solidFill>
-                <a:latin typeface="Consolas"/>
-                <a:ea typeface="맑은 고딕"/>
-              </a:rPr>
-              <a:t> </a:t>
-            </a:r>
-            <a:r>
-              <a:rPr sz="1000" b="0">
-                <a:solidFill>
-                  <a:srgbClr val="000000"/>
-                </a:solidFill>
-                <a:latin typeface="Consolas"/>
-                <a:ea typeface="맑은 고딕"/>
-              </a:rPr>
-              <a:t>IllegalStateException</a:t>
-            </a:r>
-            <a:r>
-              <a:rPr sz="1000" b="0">
-                <a:solidFill>
-                  <a:srgbClr val="000000"/>
-                </a:solidFill>
-                <a:latin typeface="Consolas"/>
-                <a:ea typeface="맑은 고딕"/>
-              </a:rPr>
-              <a:t>(상태 + </a:t>
-            </a:r>
-            <a:r>
-              <a:rPr sz="1000" b="0">
-                <a:solidFill>
-                  <a:srgbClr val="000000"/>
-                </a:solidFill>
-                <a:latin typeface="Consolas"/>
-                <a:ea typeface="맑은 고딕"/>
-              </a:rPr>
-              <a:t>"에서는 할 수 없다"</a:t>
-            </a:r>
-            <a:r>
-              <a:rPr sz="1000" b="0">
-                <a:solidFill>
-                  <a:srgbClr val="000000"/>
-                </a:solidFill>
-                <a:latin typeface="Consolas"/>
-                <a:ea typeface="맑은 고딕"/>
-              </a:rPr>
-              <a:t>);</a:t>
+              <a:t>            throw new IllegalStateException(상태 + "에서는 할 수 없다");</a:t>
             </a:r>
           </a:p>
           <a:p>
@@ -8211,8 +6856,8 @@
         </p:blipFill>
         <p:spPr>
           <a:xfrm>
-            <a:off x="2180981" y="2100036"/>
-            <a:ext cx="4782038" cy="1246554"/>
+            <a:off x="2398346" y="2100036"/>
+            <a:ext cx="4347308" cy="1133231"/>
           </a:xfrm>
           <a:prstGeom prst="rect">
             <a:avLst/>
@@ -8400,7 +7045,7 @@
                 <a:gridCol w="2959100"/>
                 <a:gridCol w="2707640"/>
               </a:tblGrid>
-              <a:tr h="317500">
+              <a:tr h="288000">
                 <a:tc>
                   <a:txBody>
                     <a:bodyPr/>
@@ -8604,7 +7249,7 @@
                   </a:tcPr>
                 </a:tc>
               </a:tr>
-              <a:tr h="317500">
+              <a:tr h="288000">
                 <a:tc>
                   <a:txBody>
                     <a:bodyPr/>
@@ -8772,7 +7417,7 @@
                   </a:tcPr>
                 </a:tc>
               </a:tr>
-              <a:tr h="317500">
+              <a:tr h="288000">
                 <a:tc>
                   <a:txBody>
                     <a:bodyPr/>
@@ -8940,7 +7585,7 @@
                   </a:tcPr>
                 </a:tc>
               </a:tr>
-              <a:tr h="317500">
+              <a:tr h="288000">
                 <a:tc>
                   <a:txBody>
                     <a:bodyPr/>
@@ -9108,7 +7753,7 @@
                   </a:tcPr>
                 </a:tc>
               </a:tr>
-              <a:tr h="317500">
+              <a:tr h="288000">
                 <a:tc>
                   <a:txBody>
                     <a:bodyPr/>
@@ -9276,7 +7921,7 @@
                   </a:tcPr>
                 </a:tc>
               </a:tr>
-              <a:tr h="317500">
+              <a:tr h="288000">
                 <a:tc>
                   <a:txBody>
                     <a:bodyPr/>
@@ -9764,7 +8409,7 @@
                 <a:gridCol w="1813560"/>
                 <a:gridCol w="1813560"/>
               </a:tblGrid>
-              <a:tr h="317500">
+              <a:tr h="288000">
                 <a:tc>
                   <a:txBody>
                     <a:bodyPr/>
@@ -9968,7 +8613,7 @@
                   </a:tcPr>
                 </a:tc>
               </a:tr>
-              <a:tr h="317500">
+              <a:tr h="288000">
                 <a:tc>
                   <a:txBody>
                     <a:bodyPr/>
@@ -10136,7 +8781,7 @@
                   </a:tcPr>
                 </a:tc>
               </a:tr>
-              <a:tr h="317500">
+              <a:tr h="288000">
                 <a:tc>
                   <a:txBody>
                     <a:bodyPr/>
@@ -10304,7 +8949,7 @@
                   </a:tcPr>
                 </a:tc>
               </a:tr>
-              <a:tr h="317500">
+              <a:tr h="288000">
                 <a:tc>
                   <a:txBody>
                     <a:bodyPr/>
@@ -10665,7 +9310,7 @@
         </p:nvSpPr>
         <p:spPr>
           <a:xfrm>
-            <a:off x="365760" y="3471636"/>
+            <a:off x="365760" y="3353636"/>
             <a:ext cx="8412480" cy="781278"/>
           </a:xfrm>
           <a:prstGeom prst="rect">
@@ -10884,7 +9529,7 @@
                 <a:gridCol w="2092960"/>
                 <a:gridCol w="1953260"/>
               </a:tblGrid>
-              <a:tr h="317500">
+              <a:tr h="288000">
                 <a:tc>
                   <a:txBody>
                     <a:bodyPr/>
@@ -11088,7 +9733,7 @@
                   </a:tcPr>
                 </a:tc>
               </a:tr>
-              <a:tr h="317500">
+              <a:tr h="288000">
                 <a:tc>
                   <a:txBody>
                     <a:bodyPr/>
@@ -11256,7 +9901,7 @@
                   </a:tcPr>
                 </a:tc>
               </a:tr>
-              <a:tr h="317500">
+              <a:tr h="288000">
                 <a:tc>
                   <a:txBody>
                     <a:bodyPr/>
@@ -11424,7 +10069,7 @@
                   </a:tcPr>
                 </a:tc>
               </a:tr>
-              <a:tr h="317500">
+              <a:tr h="288000">
                 <a:tc>
                   <a:txBody>
                     <a:bodyPr/>
@@ -11928,7 +10573,7 @@
         </p:nvSpPr>
         <p:spPr>
           <a:xfrm>
-            <a:off x="365760" y="3199280"/>
+            <a:off x="365760" y="3085957"/>
             <a:ext cx="8412480" cy="2743200"/>
           </a:xfrm>
           <a:prstGeom prst="rect">
@@ -11962,7 +10607,17 @@
                 <a:latin typeface="Consolas"/>
                 <a:ea typeface="맑은 고딕"/>
               </a:rPr>
-              <a:t>class</a:t>
+              <a:t>class </a:t>
+            </a:r>
+            <a:r>
+              <a:rPr sz="900" b="1">
+                <a:solidFill>
+                  <a:srgbClr val="000000"/>
+                </a:solidFill>
+                <a:latin typeface="Consolas"/>
+                <a:ea typeface="맑은 고딕"/>
+              </a:rPr>
+              <a:t>주문테스트</a:t>
             </a:r>
             <a:r>
               <a:rPr sz="900" b="0">
@@ -11972,7 +10627,7 @@
                 <a:latin typeface="Consolas"/>
                 <a:ea typeface="맑은 고딕"/>
               </a:rPr>
-              <a:t> 주문테스트 {</a:t>
+              <a:t> {</a:t>
             </a:r>
           </a:p>
           <a:p>
@@ -11996,7 +10651,17 @@
                 <a:latin typeface="Consolas"/>
                 <a:ea typeface="맑은 고딕"/>
               </a:rPr>
-              <a:t>    </a:t>
+              <a:t>    public static void </a:t>
+            </a:r>
+            <a:r>
+              <a:rPr sz="900" b="1">
+                <a:solidFill>
+                  <a:srgbClr val="000000"/>
+                </a:solidFill>
+                <a:latin typeface="Consolas"/>
+                <a:ea typeface="맑은 고딕"/>
+              </a:rPr>
+              <a:t>main</a:t>
             </a:r>
             <a:r>
               <a:rPr sz="900" b="0">
@@ -12006,117 +10671,7 @@
                 <a:latin typeface="Consolas"/>
                 <a:ea typeface="맑은 고딕"/>
               </a:rPr>
-              <a:t>public</a:t>
-            </a:r>
-            <a:r>
-              <a:rPr sz="900" b="0">
-                <a:solidFill>
-                  <a:srgbClr val="000000"/>
-                </a:solidFill>
-                <a:latin typeface="Consolas"/>
-                <a:ea typeface="맑은 고딕"/>
-              </a:rPr>
-              <a:t> </a:t>
-            </a:r>
-            <a:r>
-              <a:rPr sz="900" b="0">
-                <a:solidFill>
-                  <a:srgbClr val="000000"/>
-                </a:solidFill>
-                <a:latin typeface="Consolas"/>
-                <a:ea typeface="맑은 고딕"/>
-              </a:rPr>
-              <a:t>static</a:t>
-            </a:r>
-            <a:r>
-              <a:rPr sz="900" b="0">
-                <a:solidFill>
-                  <a:srgbClr val="000000"/>
-                </a:solidFill>
-                <a:latin typeface="Consolas"/>
-                <a:ea typeface="맑은 고딕"/>
-              </a:rPr>
-              <a:t> </a:t>
-            </a:r>
-            <a:r>
-              <a:rPr sz="900" b="0">
-                <a:solidFill>
-                  <a:srgbClr val="000000"/>
-                </a:solidFill>
-                <a:latin typeface="Consolas"/>
-                <a:ea typeface="맑은 고딕"/>
-              </a:rPr>
-              <a:t>void</a:t>
-            </a:r>
-            <a:r>
-              <a:rPr sz="900" b="0">
-                <a:solidFill>
-                  <a:srgbClr val="000000"/>
-                </a:solidFill>
-                <a:latin typeface="Consolas"/>
-                <a:ea typeface="맑은 고딕"/>
-              </a:rPr>
-              <a:t> </a:t>
-            </a:r>
-            <a:r>
-              <a:rPr sz="900" b="0">
-                <a:solidFill>
-                  <a:srgbClr val="000000"/>
-                </a:solidFill>
-                <a:latin typeface="Consolas"/>
-                <a:ea typeface="맑은 고딕"/>
-              </a:rPr>
-              <a:t>main</a:t>
-            </a:r>
-            <a:r>
-              <a:rPr sz="900" b="0">
-                <a:solidFill>
-                  <a:srgbClr val="000000"/>
-                </a:solidFill>
-                <a:latin typeface="Consolas"/>
-                <a:ea typeface="맑은 고딕"/>
-              </a:rPr>
-              <a:t>(</a:t>
-            </a:r>
-            <a:r>
-              <a:rPr sz="900" b="0">
-                <a:solidFill>
-                  <a:srgbClr val="000000"/>
-                </a:solidFill>
-                <a:latin typeface="Consolas"/>
-                <a:ea typeface="맑은 고딕"/>
-              </a:rPr>
-              <a:t>String</a:t>
-            </a:r>
-            <a:r>
-              <a:rPr sz="900" b="0">
-                <a:solidFill>
-                  <a:srgbClr val="000000"/>
-                </a:solidFill>
-                <a:latin typeface="Consolas"/>
-                <a:ea typeface="맑은 고딕"/>
-              </a:rPr>
-              <a:t>[] </a:t>
-            </a:r>
-            <a:r>
-              <a:rPr sz="900" b="0">
-                <a:solidFill>
-                  <a:srgbClr val="000000"/>
-                </a:solidFill>
-                <a:latin typeface="Consolas"/>
-                <a:ea typeface="맑은 고딕"/>
-              </a:rPr>
-              <a:t>args</a:t>
-            </a:r>
-            <a:r>
-              <a:rPr sz="900" b="0">
-                <a:solidFill>
-                  <a:srgbClr val="000000"/>
-                </a:solidFill>
-                <a:latin typeface="Consolas"/>
-                <a:ea typeface="맑은 고딕"/>
-              </a:rPr>
-              <a:t>) {</a:t>
+              <a:t>(String[] args) {</a:t>
             </a:r>
           </a:p>
           <a:p>
@@ -12140,47 +10695,7 @@
                 <a:latin typeface="Consolas"/>
                 <a:ea typeface="맑은 고딕"/>
               </a:rPr>
-              <a:t>        </a:t>
-            </a:r>
-            <a:r>
-              <a:rPr sz="900" b="0">
-                <a:solidFill>
-                  <a:srgbClr val="000000"/>
-                </a:solidFill>
-                <a:latin typeface="Consolas"/>
-                <a:ea typeface="맑은 고딕"/>
-              </a:rPr>
-              <a:t>var</a:t>
-            </a:r>
-            <a:r>
-              <a:rPr sz="900" b="0">
-                <a:solidFill>
-                  <a:srgbClr val="000000"/>
-                </a:solidFill>
-                <a:latin typeface="Consolas"/>
-                <a:ea typeface="맑은 고딕"/>
-              </a:rPr>
-              <a:t> 배송된주문 = </a:t>
-            </a:r>
-            <a:r>
-              <a:rPr sz="900" b="0">
-                <a:solidFill>
-                  <a:srgbClr val="000000"/>
-                </a:solidFill>
-                <a:latin typeface="Consolas"/>
-                <a:ea typeface="맑은 고딕"/>
-              </a:rPr>
-              <a:t>new</a:t>
-            </a:r>
-            <a:r>
-              <a:rPr sz="900" b="0">
-                <a:solidFill>
-                  <a:srgbClr val="000000"/>
-                </a:solidFill>
-                <a:latin typeface="Consolas"/>
-                <a:ea typeface="맑은 고딕"/>
-              </a:rPr>
-              <a:t> 주문();</a:t>
+              <a:t>        var 배송된주문 = new 주문();</a:t>
             </a:r>
           </a:p>
           <a:p>
@@ -12290,47 +10805,7 @@
                 <a:latin typeface="Consolas"/>
                 <a:ea typeface="맑은 고딕"/>
               </a:rPr>
-              <a:t>        </a:t>
-            </a:r>
-            <a:r>
-              <a:rPr sz="900" b="0">
-                <a:solidFill>
-                  <a:srgbClr val="000000"/>
-                </a:solidFill>
-                <a:latin typeface="Consolas"/>
-                <a:ea typeface="맑은 고딕"/>
-              </a:rPr>
-              <a:t>var</a:t>
-            </a:r>
-            <a:r>
-              <a:rPr sz="900" b="0">
-                <a:solidFill>
-                  <a:srgbClr val="000000"/>
-                </a:solidFill>
-                <a:latin typeface="Consolas"/>
-                <a:ea typeface="맑은 고딕"/>
-              </a:rPr>
-              <a:t> 취소된주문 = </a:t>
-            </a:r>
-            <a:r>
-              <a:rPr sz="900" b="0">
-                <a:solidFill>
-                  <a:srgbClr val="000000"/>
-                </a:solidFill>
-                <a:latin typeface="Consolas"/>
-                <a:ea typeface="맑은 고딕"/>
-              </a:rPr>
-              <a:t>new</a:t>
-            </a:r>
-            <a:r>
-              <a:rPr sz="900" b="0">
-                <a:solidFill>
-                  <a:srgbClr val="000000"/>
-                </a:solidFill>
-                <a:latin typeface="Consolas"/>
-                <a:ea typeface="맑은 고딕"/>
-              </a:rPr>
-              <a:t> 주문();</a:t>
+              <a:t>        var 취소된주문 = new 주문();</a:t>
             </a:r>
           </a:p>
           <a:p>
@@ -12416,87 +10891,7 @@
                 <a:latin typeface="Consolas"/>
                 <a:ea typeface="맑은 고딕"/>
               </a:rPr>
-              <a:t>        </a:t>
-            </a:r>
-            <a:r>
-              <a:rPr sz="900" b="0">
-                <a:solidFill>
-                  <a:srgbClr val="000000"/>
-                </a:solidFill>
-                <a:latin typeface="Consolas"/>
-                <a:ea typeface="맑은 고딕"/>
-              </a:rPr>
-              <a:t>System</a:t>
-            </a:r>
-            <a:r>
-              <a:rPr sz="900" b="0">
-                <a:solidFill>
-                  <a:srgbClr val="000000"/>
-                </a:solidFill>
-                <a:latin typeface="Consolas"/>
-                <a:ea typeface="맑은 고딕"/>
-              </a:rPr>
-              <a:t>.</a:t>
-            </a:r>
-            <a:r>
-              <a:rPr sz="900" b="0">
-                <a:solidFill>
-                  <a:srgbClr val="000000"/>
-                </a:solidFill>
-                <a:latin typeface="Consolas"/>
-                <a:ea typeface="맑은 고딕"/>
-              </a:rPr>
-              <a:t>out</a:t>
-            </a:r>
-            <a:r>
-              <a:rPr sz="900" b="0">
-                <a:solidFill>
-                  <a:srgbClr val="000000"/>
-                </a:solidFill>
-                <a:latin typeface="Consolas"/>
-                <a:ea typeface="맑은 고딕"/>
-              </a:rPr>
-              <a:t>.</a:t>
-            </a:r>
-            <a:r>
-              <a:rPr sz="900" b="0">
-                <a:solidFill>
-                  <a:srgbClr val="000000"/>
-                </a:solidFill>
-                <a:latin typeface="Consolas"/>
-                <a:ea typeface="맑은 고딕"/>
-              </a:rPr>
-              <a:t>println</a:t>
-            </a:r>
-            <a:r>
-              <a:rPr sz="900" b="0">
-                <a:solidFill>
-                  <a:srgbClr val="000000"/>
-                </a:solidFill>
-                <a:latin typeface="Consolas"/>
-                <a:ea typeface="맑은 고딕"/>
-              </a:rPr>
-              <a:t>(</a:t>
-            </a:r>
-            <a:r>
-              <a:rPr sz="900" b="0">
-                <a:solidFill>
-                  <a:srgbClr val="000000"/>
-                </a:solidFill>
-                <a:latin typeface="Consolas"/>
-                <a:ea typeface="맑은 고딕"/>
-              </a:rPr>
-              <a:t>"주문 규칙 확인"</a:t>
-            </a:r>
-            <a:r>
-              <a:rPr sz="900" b="0">
-                <a:solidFill>
-                  <a:srgbClr val="000000"/>
-                </a:solidFill>
-                <a:latin typeface="Consolas"/>
-                <a:ea typeface="맑은 고딕"/>
-              </a:rPr>
-              <a:t>);</a:t>
+              <a:t>        System.out.println("주문 규칙 확인");</a:t>
             </a:r>
           </a:p>
           <a:p>
@@ -12558,7 +10953,17 @@
                 <a:latin typeface="Consolas"/>
                 <a:ea typeface="맑은 고딕"/>
               </a:rPr>
-              <a:t>    </a:t>
+              <a:t>    static void </a:t>
+            </a:r>
+            <a:r>
+              <a:rPr sz="900" b="1">
+                <a:solidFill>
+                  <a:srgbClr val="000000"/>
+                </a:solidFill>
+                <a:latin typeface="Consolas"/>
+                <a:ea typeface="맑은 고딕"/>
+              </a:rPr>
+              <a:t>거절</a:t>
             </a:r>
             <a:r>
               <a:rPr sz="900" b="0">
@@ -12568,57 +10973,7 @@
                 <a:latin typeface="Consolas"/>
                 <a:ea typeface="맑은 고딕"/>
               </a:rPr>
-              <a:t>static</a:t>
-            </a:r>
-            <a:r>
-              <a:rPr sz="900" b="0">
-                <a:solidFill>
-                  <a:srgbClr val="000000"/>
-                </a:solidFill>
-                <a:latin typeface="Consolas"/>
-                <a:ea typeface="맑은 고딕"/>
-              </a:rPr>
-              <a:t> </a:t>
-            </a:r>
-            <a:r>
-              <a:rPr sz="900" b="0">
-                <a:solidFill>
-                  <a:srgbClr val="000000"/>
-                </a:solidFill>
-                <a:latin typeface="Consolas"/>
-                <a:ea typeface="맑은 고딕"/>
-              </a:rPr>
-              <a:t>void</a:t>
-            </a:r>
-            <a:r>
-              <a:rPr sz="900" b="0">
-                <a:solidFill>
-                  <a:srgbClr val="000000"/>
-                </a:solidFill>
-                <a:latin typeface="Consolas"/>
-                <a:ea typeface="맑은 고딕"/>
-              </a:rPr>
-              <a:t> 거절(</a:t>
-            </a:r>
-            <a:r>
-              <a:rPr sz="900" b="0">
-                <a:solidFill>
-                  <a:srgbClr val="000000"/>
-                </a:solidFill>
-                <a:latin typeface="Consolas"/>
-                <a:ea typeface="맑은 고딕"/>
-              </a:rPr>
-              <a:t>Runnable</a:t>
-            </a:r>
-            <a:r>
-              <a:rPr sz="900" b="0">
-                <a:solidFill>
-                  <a:srgbClr val="000000"/>
-                </a:solidFill>
-                <a:latin typeface="Consolas"/>
-                <a:ea typeface="맑은 고딕"/>
-              </a:rPr>
-              <a:t> 행위) {</a:t>
+              <a:t>(Runnable 행위) {</a:t>
             </a:r>
           </a:p>
           <a:p>
@@ -12642,107 +10997,7 @@
                 <a:latin typeface="Consolas"/>
                 <a:ea typeface="맑은 고딕"/>
               </a:rPr>
-              <a:t>        </a:t>
-            </a:r>
-            <a:r>
-              <a:rPr sz="900" b="0">
-                <a:solidFill>
-                  <a:srgbClr val="000000"/>
-                </a:solidFill>
-                <a:latin typeface="Consolas"/>
-                <a:ea typeface="맑은 고딕"/>
-              </a:rPr>
-              <a:t>try</a:t>
-            </a:r>
-            <a:r>
-              <a:rPr sz="900" b="0">
-                <a:solidFill>
-                  <a:srgbClr val="000000"/>
-                </a:solidFill>
-                <a:latin typeface="Consolas"/>
-                <a:ea typeface="맑은 고딕"/>
-              </a:rPr>
-              <a:t> { 행위.</a:t>
-            </a:r>
-            <a:r>
-              <a:rPr sz="900" b="0">
-                <a:solidFill>
-                  <a:srgbClr val="000000"/>
-                </a:solidFill>
-                <a:latin typeface="Consolas"/>
-                <a:ea typeface="맑은 고딕"/>
-              </a:rPr>
-              <a:t>run</a:t>
-            </a:r>
-            <a:r>
-              <a:rPr sz="900" b="0">
-                <a:solidFill>
-                  <a:srgbClr val="000000"/>
-                </a:solidFill>
-                <a:latin typeface="Consolas"/>
-                <a:ea typeface="맑은 고딕"/>
-              </a:rPr>
-              <a:t>(); } </a:t>
-            </a:r>
-            <a:r>
-              <a:rPr sz="900" b="0">
-                <a:solidFill>
-                  <a:srgbClr val="000000"/>
-                </a:solidFill>
-                <a:latin typeface="Consolas"/>
-                <a:ea typeface="맑은 고딕"/>
-              </a:rPr>
-              <a:t>catch</a:t>
-            </a:r>
-            <a:r>
-              <a:rPr sz="900" b="0">
-                <a:solidFill>
-                  <a:srgbClr val="000000"/>
-                </a:solidFill>
-                <a:latin typeface="Consolas"/>
-                <a:ea typeface="맑은 고딕"/>
-              </a:rPr>
-              <a:t> (</a:t>
-            </a:r>
-            <a:r>
-              <a:rPr sz="900" b="0">
-                <a:solidFill>
-                  <a:srgbClr val="000000"/>
-                </a:solidFill>
-                <a:latin typeface="Consolas"/>
-                <a:ea typeface="맑은 고딕"/>
-              </a:rPr>
-              <a:t>IllegalStateException</a:t>
-            </a:r>
-            <a:r>
-              <a:rPr sz="900" b="0">
-                <a:solidFill>
-                  <a:srgbClr val="000000"/>
-                </a:solidFill>
-                <a:latin typeface="Consolas"/>
-                <a:ea typeface="맑은 고딕"/>
-              </a:rPr>
-              <a:t> 기대한거절) { </a:t>
-            </a:r>
-            <a:r>
-              <a:rPr sz="900" b="0">
-                <a:solidFill>
-                  <a:srgbClr val="000000"/>
-                </a:solidFill>
-                <a:latin typeface="Consolas"/>
-                <a:ea typeface="맑은 고딕"/>
-              </a:rPr>
-              <a:t>return</a:t>
-            </a:r>
-            <a:r>
-              <a:rPr sz="900" b="0">
-                <a:solidFill>
-                  <a:srgbClr val="000000"/>
-                </a:solidFill>
-                <a:latin typeface="Consolas"/>
-                <a:ea typeface="맑은 고딕"/>
-              </a:rPr>
-              <a:t>; }</a:t>
+              <a:t>        try { 행위.run(); } catch (IllegalStateException 기대한거절) { return; }</a:t>
             </a:r>
           </a:p>
           <a:p>
@@ -12766,87 +11021,7 @@
                 <a:latin typeface="Consolas"/>
                 <a:ea typeface="맑은 고딕"/>
               </a:rPr>
-              <a:t>        </a:t>
-            </a:r>
-            <a:r>
-              <a:rPr sz="900" b="0">
-                <a:solidFill>
-                  <a:srgbClr val="000000"/>
-                </a:solidFill>
-                <a:latin typeface="Consolas"/>
-                <a:ea typeface="맑은 고딕"/>
-              </a:rPr>
-              <a:t>throw</a:t>
-            </a:r>
-            <a:r>
-              <a:rPr sz="900" b="0">
-                <a:solidFill>
-                  <a:srgbClr val="000000"/>
-                </a:solidFill>
-                <a:latin typeface="Consolas"/>
-                <a:ea typeface="맑은 고딕"/>
-              </a:rPr>
-              <a:t> </a:t>
-            </a:r>
-            <a:r>
-              <a:rPr sz="900" b="0">
-                <a:solidFill>
-                  <a:srgbClr val="000000"/>
-                </a:solidFill>
-                <a:latin typeface="Consolas"/>
-                <a:ea typeface="맑은 고딕"/>
-              </a:rPr>
-              <a:t>new</a:t>
-            </a:r>
-            <a:r>
-              <a:rPr sz="900" b="0">
-                <a:solidFill>
-                  <a:srgbClr val="000000"/>
-                </a:solidFill>
-                <a:latin typeface="Consolas"/>
-                <a:ea typeface="맑은 고딕"/>
-              </a:rPr>
-              <a:t> </a:t>
-            </a:r>
-            <a:r>
-              <a:rPr sz="900" b="0">
-                <a:solidFill>
-                  <a:srgbClr val="000000"/>
-                </a:solidFill>
-                <a:latin typeface="Consolas"/>
-                <a:ea typeface="맑은 고딕"/>
-              </a:rPr>
-              <a:t>AssertionError</a:t>
-            </a:r>
-            <a:r>
-              <a:rPr sz="900" b="0">
-                <a:solidFill>
-                  <a:srgbClr val="000000"/>
-                </a:solidFill>
-                <a:latin typeface="Consolas"/>
-                <a:ea typeface="맑은 고딕"/>
-              </a:rPr>
-              <a:t>(</a:t>
-            </a:r>
-            <a:r>
-              <a:rPr sz="900" b="0">
-                <a:solidFill>
-                  <a:srgbClr val="000000"/>
-                </a:solidFill>
-                <a:latin typeface="Consolas"/>
-                <a:ea typeface="맑은 고딕"/>
-              </a:rPr>
-              <a:t>"거절되어야 한다"</a:t>
-            </a:r>
-            <a:r>
-              <a:rPr sz="900" b="0">
-                <a:solidFill>
-                  <a:srgbClr val="000000"/>
-                </a:solidFill>
-                <a:latin typeface="Consolas"/>
-                <a:ea typeface="맑은 고딕"/>
-              </a:rPr>
-              <a:t>);</a:t>
+              <a:t>        throw new AssertionError("거절되어야 한다");</a:t>
             </a:r>
           </a:p>
           <a:p>
@@ -12985,8 +11160,8 @@
         </p:blipFill>
         <p:spPr>
           <a:xfrm>
-            <a:off x="2180981" y="1842998"/>
-            <a:ext cx="4782038" cy="1246554"/>
+            <a:off x="2398346" y="1842998"/>
+            <a:ext cx="4347308" cy="1133231"/>
           </a:xfrm>
           <a:prstGeom prst="rect">
             <a:avLst/>
@@ -13095,11 +11270,6 @@
               </a:rPr>
               <a:t>- 2 -</a:t>
             </a:r>
-            <a:endParaRPr lang="ko-KR" altLang="en-US" dirty="0">
-              <a:solidFill>
-                <a:prstClr val="black"/>
-              </a:solidFill>
-            </a:endParaRPr>
           </a:p>
         </p:txBody>
       </p:sp>
@@ -13873,7 +12043,7 @@
                 <a:gridCol w="4188460"/>
                 <a:gridCol w="2959100"/>
               </a:tblGrid>
-              <a:tr h="317500">
+              <a:tr h="288000">
                 <a:tc>
                   <a:txBody>
                     <a:bodyPr/>
@@ -14077,7 +12247,7 @@
                   </a:tcPr>
                 </a:tc>
               </a:tr>
-              <a:tr h="317500">
+              <a:tr h="288000">
                 <a:tc>
                   <a:txBody>
                     <a:bodyPr/>
@@ -14245,7 +12415,7 @@
                   </a:tcPr>
                 </a:tc>
               </a:tr>
-              <a:tr h="317500">
+              <a:tr h="288000">
                 <a:tc>
                   <a:txBody>
                     <a:bodyPr/>
@@ -14413,7 +12583,7 @@
                   </a:tcPr>
                 </a:tc>
               </a:tr>
-              <a:tr h="317500">
+              <a:tr h="288000">
                 <a:tc>
                   <a:txBody>
                     <a:bodyPr/>
@@ -14581,7 +12751,7 @@
                   </a:tcPr>
                 </a:tc>
               </a:tr>
-              <a:tr h="317500">
+              <a:tr h="288000">
                 <a:tc>
                   <a:txBody>
                     <a:bodyPr/>
@@ -14912,7 +13082,7 @@
         </p:nvSpPr>
         <p:spPr>
           <a:xfrm>
-            <a:off x="365760" y="3789136"/>
+            <a:off x="365760" y="3641636"/>
             <a:ext cx="8412480" cy="781278"/>
           </a:xfrm>
           <a:prstGeom prst="rect">
@@ -15171,7 +13341,7 @@
                 <a:gridCol w="2651760"/>
                 <a:gridCol w="3182620"/>
               </a:tblGrid>
-              <a:tr h="317500">
+              <a:tr h="288000">
                 <a:tc>
                   <a:txBody>
                     <a:bodyPr/>
@@ -15375,7 +13545,7 @@
                   </a:tcPr>
                 </a:tc>
               </a:tr>
-              <a:tr h="317500">
+              <a:tr h="288000">
                 <a:tc>
                   <a:txBody>
                     <a:bodyPr/>
@@ -15543,7 +13713,7 @@
                   </a:tcPr>
                 </a:tc>
               </a:tr>
-              <a:tr h="317500">
+              <a:tr h="288000">
                 <a:tc>
                   <a:txBody>
                     <a:bodyPr/>
@@ -15711,7 +13881,7 @@
                   </a:tcPr>
                 </a:tc>
               </a:tr>
-              <a:tr h="317500">
+              <a:tr h="288000">
                 <a:tc>
                   <a:txBody>
                     <a:bodyPr/>
@@ -15879,7 +14049,7 @@
                   </a:tcPr>
                 </a:tc>
               </a:tr>
-              <a:tr h="317500">
+              <a:tr h="288000">
                 <a:tc>
                   <a:txBody>
                     <a:bodyPr/>
@@ -16377,7 +14547,7 @@
                 <a:gridCol w="3296815"/>
                 <a:gridCol w="3998214"/>
               </a:tblGrid>
-              <a:tr h="317500">
+              <a:tr h="288000">
                 <a:tc>
                   <a:txBody>
                     <a:bodyPr/>
@@ -16581,7 +14751,7 @@
                   </a:tcPr>
                 </a:tc>
               </a:tr>
-              <a:tr h="317500">
+              <a:tr h="288000">
                 <a:tc>
                   <a:txBody>
                     <a:bodyPr/>
@@ -16749,7 +14919,7 @@
                   </a:tcPr>
                 </a:tc>
               </a:tr>
-              <a:tr h="317500">
+              <a:tr h="288000">
                 <a:tc>
                   <a:txBody>
                     <a:bodyPr/>
@@ -16917,7 +15087,7 @@
                   </a:tcPr>
                 </a:tc>
               </a:tr>
-              <a:tr h="317500">
+              <a:tr h="288000">
                 <a:tc>
                   <a:txBody>
                     <a:bodyPr/>
@@ -17085,7 +15255,7 @@
                   </a:tcPr>
                 </a:tc>
               </a:tr>
-              <a:tr h="317500">
+              <a:tr h="288000">
                 <a:tc>
                   <a:txBody>
                     <a:bodyPr/>
@@ -17416,7 +15586,7 @@
         </p:nvSpPr>
         <p:spPr>
           <a:xfrm>
-            <a:off x="365760" y="3532098"/>
+            <a:off x="365760" y="3384598"/>
             <a:ext cx="8412480" cy="524240"/>
           </a:xfrm>
           <a:prstGeom prst="rect">
@@ -17505,7 +15675,7 @@
           </p:nvPr>
         </p:nvGraphicFramePr>
         <p:xfrm>
-          <a:off x="412306" y="4157938"/>
+          <a:off x="412306" y="4010438"/>
           <a:ext cx="8305800" cy="3873500"/>
         </p:xfrm>
         <a:graphic>
@@ -17517,7 +15687,7 @@
                 <a:gridCol w="3296815"/>
                 <a:gridCol w="3998214"/>
               </a:tblGrid>
-              <a:tr h="317500">
+              <a:tr h="288000">
                 <a:tc>
                   <a:txBody>
                     <a:bodyPr/>
@@ -17721,7 +15891,7 @@
                   </a:tcPr>
                 </a:tc>
               </a:tr>
-              <a:tr h="317500">
+              <a:tr h="288000">
                 <a:tc>
                   <a:txBody>
                     <a:bodyPr/>
@@ -17889,7 +16059,7 @@
                   </a:tcPr>
                 </a:tc>
               </a:tr>
-              <a:tr h="317500">
+              <a:tr h="288000">
                 <a:tc>
                   <a:txBody>
                     <a:bodyPr/>
@@ -18057,7 +16227,7 @@
                   </a:tcPr>
                 </a:tc>
               </a:tr>
-              <a:tr h="317500">
+              <a:tr h="288000">
                 <a:tc>
                   <a:txBody>
                     <a:bodyPr/>
@@ -18225,7 +16395,7 @@
                   </a:tcPr>
                 </a:tc>
               </a:tr>
-              <a:tr h="317500">
+              <a:tr h="288000">
                 <a:tc>
                   <a:txBody>
                     <a:bodyPr/>
@@ -18393,7 +16563,7 @@
                   </a:tcPr>
                 </a:tc>
               </a:tr>
-              <a:tr h="317500">
+              <a:tr h="288000">
                 <a:tc>
                   <a:txBody>
                     <a:bodyPr/>
@@ -18745,7 +16915,7 @@
                 <a:gridCol w="2819400"/>
                 <a:gridCol w="3629660"/>
               </a:tblGrid>
-              <a:tr h="317500">
+              <a:tr h="288000">
                 <a:tc>
                   <a:txBody>
                     <a:bodyPr/>
@@ -18879,7 +17049,7 @@
                   </a:tcPr>
                 </a:tc>
               </a:tr>
-              <a:tr h="317500">
+              <a:tr h="288000">
                 <a:tc>
                   <a:txBody>
                     <a:bodyPr/>
@@ -18991,7 +17161,7 @@
                   </a:tcPr>
                 </a:tc>
               </a:tr>
-              <a:tr h="317500">
+              <a:tr h="288000">
                 <a:tc>
                   <a:txBody>
                     <a:bodyPr/>
@@ -19064,7 +17234,7 @@
                           <a:ea typeface="맑은 고딕" panose="020B0503020000020004" pitchFamily="34" charset="-127"/>
                           <a:cs typeface="맑은 고딕"/>
                         </a:rPr>
-                        <a:t>경계와 계약 — 누가 취소를 판단하는가</a:t>
+                        <a:t>경계와 계약 — 누가 취소를 판단하는가?</a:t>
                       </a:r>
                     </a:p>
                   </a:txBody>
@@ -19103,7 +17273,7 @@
                   </a:tcPr>
                 </a:tc>
               </a:tr>
-              <a:tr h="317500">
+              <a:tr h="288000">
                 <a:tc>
                   <a:txBody>
                     <a:bodyPr/>
@@ -19378,7 +17548,7 @@
         </p:nvSpPr>
         <p:spPr>
           <a:xfrm>
-            <a:off x="365760" y="3471636"/>
+            <a:off x="365760" y="3353636"/>
             <a:ext cx="8412480" cy="781278"/>
           </a:xfrm>
           <a:prstGeom prst="rect">
@@ -19616,7 +17786,7 @@
                 <a:gridCol w="1534160"/>
                 <a:gridCol w="4607560"/>
               </a:tblGrid>
-              <a:tr h="317500">
+              <a:tr h="288000">
                 <a:tc>
                   <a:txBody>
                     <a:bodyPr/>
@@ -19750,7 +17920,7 @@
                   </a:tcPr>
                 </a:tc>
               </a:tr>
-              <a:tr h="317500">
+              <a:tr h="288000">
                 <a:tc>
                   <a:txBody>
                     <a:bodyPr/>
@@ -19862,7 +18032,7 @@
                   </a:tcPr>
                 </a:tc>
               </a:tr>
-              <a:tr h="317500">
+              <a:tr h="288000">
                 <a:tc>
                   <a:txBody>
                     <a:bodyPr/>
@@ -19974,7 +18144,7 @@
                   </a:tcPr>
                 </a:tc>
               </a:tr>
-              <a:tr h="317500">
+              <a:tr h="288000">
                 <a:tc>
                   <a:txBody>
                     <a:bodyPr/>
@@ -20086,7 +18256,7 @@
                   </a:tcPr>
                 </a:tc>
               </a:tr>
-              <a:tr h="317500">
+              <a:tr h="288000">
                 <a:tc>
                   <a:txBody>
                     <a:bodyPr/>
@@ -20518,7 +18688,7 @@
                 <a:gridCol w="2567940"/>
                 <a:gridCol w="2232660"/>
               </a:tblGrid>
-              <a:tr h="317500">
+              <a:tr h="288000">
                 <a:tc>
                   <a:txBody>
                     <a:bodyPr/>
@@ -20722,7 +18892,7 @@
                   </a:tcPr>
                 </a:tc>
               </a:tr>
-              <a:tr h="317500">
+              <a:tr h="288000">
                 <a:tc>
                   <a:txBody>
                     <a:bodyPr/>
@@ -20890,7 +19060,7 @@
                   </a:tcPr>
                 </a:tc>
               </a:tr>
-              <a:tr h="317500">
+              <a:tr h="288000">
                 <a:tc>
                   <a:txBody>
                     <a:bodyPr/>
@@ -21058,7 +19228,7 @@
                   </a:tcPr>
                 </a:tc>
               </a:tr>
-              <a:tr h="317500">
+              <a:tr h="288000">
                 <a:tc>
                   <a:txBody>
                     <a:bodyPr/>
@@ -21226,7 +19396,7 @@
                   </a:tcPr>
                 </a:tc>
               </a:tr>
-              <a:tr h="317500">
+              <a:tr h="288000">
                 <a:tc>
                   <a:txBody>
                     <a:bodyPr/>
@@ -21704,7 +19874,7 @@
                 <a:gridCol w="1673860"/>
                 <a:gridCol w="2987040"/>
               </a:tblGrid>
-              <a:tr h="317500">
+              <a:tr h="288000">
                 <a:tc>
                   <a:txBody>
                     <a:bodyPr/>
@@ -21908,7 +20078,7 @@
                   </a:tcPr>
                 </a:tc>
               </a:tr>
-              <a:tr h="317500">
+              <a:tr h="288000">
                 <a:tc>
                   <a:txBody>
                     <a:bodyPr/>
@@ -22076,7 +20246,7 @@
                   </a:tcPr>
                 </a:tc>
               </a:tr>
-              <a:tr h="317500">
+              <a:tr h="288000">
                 <a:tc>
                   <a:txBody>
                     <a:bodyPr/>
@@ -22244,7 +20414,7 @@
                   </a:tcPr>
                 </a:tc>
               </a:tr>
-              <a:tr h="317500">
+              <a:tr h="288000">
                 <a:tc>
                   <a:txBody>
                     <a:bodyPr/>
@@ -22412,7 +20582,7 @@
                   </a:tcPr>
                 </a:tc>
               </a:tr>
-              <a:tr h="317500">
+              <a:tr h="288000">
                 <a:tc>
                   <a:txBody>
                     <a:bodyPr/>
@@ -22580,7 +20750,7 @@
                   </a:tcPr>
                 </a:tc>
               </a:tr>
-              <a:tr h="317500">
+              <a:tr h="288000">
                 <a:tc>
                   <a:txBody>
                     <a:bodyPr/>
@@ -22901,7 +21071,7 @@
         </p:nvSpPr>
         <p:spPr>
           <a:xfrm>
-            <a:off x="365760" y="3849598"/>
+            <a:off x="365760" y="3672598"/>
             <a:ext cx="8412480" cy="781278"/>
           </a:xfrm>
           <a:prstGeom prst="rect">
@@ -23139,7 +21309,7 @@
                 <a:gridCol w="1590040"/>
                 <a:gridCol w="4691380"/>
               </a:tblGrid>
-              <a:tr h="317500">
+              <a:tr h="288000">
                 <a:tc>
                   <a:txBody>
                     <a:bodyPr/>
@@ -23273,7 +21443,7 @@
                   </a:tcPr>
                 </a:tc>
               </a:tr>
-              <a:tr h="317500">
+              <a:tr h="288000">
                 <a:tc>
                   <a:txBody>
                     <a:bodyPr/>
@@ -23385,7 +21555,7 @@
                   </a:tcPr>
                 </a:tc>
               </a:tr>
-              <a:tr h="317500">
+              <a:tr h="288000">
                 <a:tc>
                   <a:txBody>
                     <a:bodyPr/>
@@ -23497,7 +21667,7 @@
                   </a:tcPr>
                 </a:tc>
               </a:tr>
-              <a:tr h="317500">
+              <a:tr h="288000">
                 <a:tc>
                   <a:txBody>
                     <a:bodyPr/>
@@ -23609,7 +21779,7 @@
                   </a:tcPr>
                 </a:tc>
               </a:tr>
-              <a:tr h="317500">
+              <a:tr h="288000">
                 <a:tc>
                   <a:txBody>
                     <a:bodyPr/>
@@ -23721,7 +21891,7 @@
                   </a:tcPr>
                 </a:tc>
               </a:tr>
-              <a:tr h="317500">
+              <a:tr h="288000">
                 <a:tc>
                   <a:txBody>
                     <a:bodyPr/>
@@ -23986,7 +22156,7 @@
         </p:nvSpPr>
         <p:spPr>
           <a:xfrm>
-            <a:off x="365760" y="3849598"/>
+            <a:off x="365760" y="3672598"/>
             <a:ext cx="8412480" cy="781278"/>
           </a:xfrm>
           <a:prstGeom prst="rect">
@@ -24444,7 +22614,7 @@
                 <a:gridCol w="1925320"/>
                 <a:gridCol w="2148840"/>
               </a:tblGrid>
-              <a:tr h="317500">
+              <a:tr h="288000">
                 <a:tc>
                   <a:txBody>
                     <a:bodyPr/>
@@ -24718,7 +22888,7 @@
                   </a:tcPr>
                 </a:tc>
               </a:tr>
-              <a:tr h="317500">
+              <a:tr h="288000">
                 <a:tc>
                   <a:txBody>
                     <a:bodyPr/>
@@ -24942,7 +23112,7 @@
                   </a:tcPr>
                 </a:tc>
               </a:tr>
-              <a:tr h="317500">
+              <a:tr h="288000">
                 <a:tc>
                   <a:txBody>
                     <a:bodyPr/>
@@ -25166,7 +23336,7 @@
                   </a:tcPr>
                 </a:tc>
               </a:tr>
-              <a:tr h="317500">
+              <a:tr h="288000">
                 <a:tc>
                   <a:txBody>
                     <a:bodyPr/>
@@ -25390,7 +23560,7 @@
                   </a:tcPr>
                 </a:tc>
               </a:tr>
-              <a:tr h="317500">
+              <a:tr h="288000">
                 <a:tc>
                   <a:txBody>
                     <a:bodyPr/>
@@ -26128,8 +24298,8 @@
         </p:blipFill>
         <p:spPr>
           <a:xfrm>
-            <a:off x="1472406" y="4097375"/>
-            <a:ext cx="6199188" cy="820738"/>
+            <a:off x="1754188" y="4134681"/>
+            <a:ext cx="5635625" cy="746125"/>
           </a:xfrm>
           <a:prstGeom prst="rect">
             <a:avLst/>
@@ -26313,11 +24483,11 @@
             <a:tbl>
               <a:tblPr/>
               <a:tblGrid>
-                <a:gridCol w="1549529"/>
-                <a:gridCol w="3322723"/>
-                <a:gridCol w="3433548"/>
+                <a:gridCol w="1953260"/>
+                <a:gridCol w="4188460"/>
+                <a:gridCol w="2164080"/>
               </a:tblGrid>
-              <a:tr h="317500">
+              <a:tr h="288000">
                 <a:tc>
                   <a:txBody>
                     <a:bodyPr/>
@@ -26521,7 +24691,7 @@
                   </a:tcPr>
                 </a:tc>
               </a:tr>
-              <a:tr h="482600">
+              <a:tr h="440400">
                 <a:tc>
                   <a:txBody>
                     <a:bodyPr/>
@@ -26689,7 +24859,7 @@
                   </a:tcPr>
                 </a:tc>
               </a:tr>
-              <a:tr h="482600">
+              <a:tr h="440400">
                 <a:tc>
                   <a:txBody>
                     <a:bodyPr/>
@@ -26857,7 +25027,7 @@
                   </a:tcPr>
                 </a:tc>
               </a:tr>
-              <a:tr h="482600">
+              <a:tr h="440400">
                 <a:tc>
                   <a:txBody>
                     <a:bodyPr/>
@@ -27025,7 +25195,7 @@
                   </a:tcPr>
                 </a:tc>
               </a:tr>
-              <a:tr h="482600">
+              <a:tr h="440400">
                 <a:tc>
                   <a:txBody>
                     <a:bodyPr/>
@@ -27346,7 +25516,7 @@
         </p:nvSpPr>
         <p:spPr>
           <a:xfrm>
-            <a:off x="365760" y="4449536"/>
+            <a:off x="365760" y="4251236"/>
             <a:ext cx="8412480" cy="781278"/>
           </a:xfrm>
           <a:prstGeom prst="rect">
@@ -27561,11 +25731,11 @@
             <a:tbl>
               <a:tblPr/>
               <a:tblGrid>
-                <a:gridCol w="3502118"/>
-                <a:gridCol w="2496926"/>
-                <a:gridCol w="2306755"/>
+                <a:gridCol w="3365500"/>
+                <a:gridCol w="2567940"/>
+                <a:gridCol w="2372360"/>
               </a:tblGrid>
-              <a:tr h="317500">
+              <a:tr h="288000">
                 <a:tc>
                   <a:txBody>
                     <a:bodyPr/>
@@ -27769,7 +25939,7 @@
                   </a:tcPr>
                 </a:tc>
               </a:tr>
-              <a:tr h="317500">
+              <a:tr h="288000">
                 <a:tc>
                   <a:txBody>
                     <a:bodyPr/>
@@ -27937,7 +26107,7 @@
                   </a:tcPr>
                 </a:tc>
               </a:tr>
-              <a:tr h="317500">
+              <a:tr h="288000">
                 <a:tc>
                   <a:txBody>
                     <a:bodyPr/>
@@ -28105,7 +26275,7 @@
                   </a:tcPr>
                 </a:tc>
               </a:tr>
-              <a:tr h="317500">
+              <a:tr h="288000">
                 <a:tc>
                   <a:txBody>
                     <a:bodyPr/>
@@ -28273,7 +26443,7 @@
                   </a:tcPr>
                 </a:tc>
               </a:tr>
-              <a:tr h="317500">
+              <a:tr h="288000">
                 <a:tc>
                   <a:txBody>
                     <a:bodyPr/>
@@ -28441,7 +26611,7 @@
                   </a:tcPr>
                 </a:tc>
               </a:tr>
-              <a:tr h="317500">
+              <a:tr h="288000">
                 <a:tc>
                   <a:txBody>
                     <a:bodyPr/>
@@ -28609,7 +26779,7 @@
                   </a:tcPr>
                 </a:tc>
               </a:tr>
-              <a:tr h="317500">
+              <a:tr h="288000">
                 <a:tc>
                   <a:txBody>
                     <a:bodyPr/>
@@ -29098,7 +27268,7 @@
                 <a:gridCol w="1981200"/>
                 <a:gridCol w="3154680"/>
               </a:tblGrid>
-              <a:tr h="317500">
+              <a:tr h="288000">
                 <a:tc>
                   <a:txBody>
                     <a:bodyPr/>
@@ -29372,7 +27542,7 @@
                   </a:tcPr>
                 </a:tc>
               </a:tr>
-              <a:tr h="317500">
+              <a:tr h="288000">
                 <a:tc>
                   <a:txBody>
                     <a:bodyPr/>
@@ -29596,7 +27766,7 @@
                   </a:tcPr>
                 </a:tc>
               </a:tr>
-              <a:tr h="317500">
+              <a:tr h="288000">
                 <a:tc>
                   <a:txBody>
                     <a:bodyPr/>
@@ -29820,7 +27990,7 @@
                   </a:tcPr>
                 </a:tc>
               </a:tr>
-              <a:tr h="317500">
+              <a:tr h="288000">
                 <a:tc>
                   <a:txBody>
                     <a:bodyPr/>
@@ -30044,7 +28214,7 @@
                   </a:tcPr>
                 </a:tc>
               </a:tr>
-              <a:tr h="317500">
+              <a:tr h="288000">
                 <a:tc>
                   <a:txBody>
                     <a:bodyPr/>
@@ -30268,7 +28438,7 @@
                   </a:tcPr>
                 </a:tc>
               </a:tr>
-              <a:tr h="317500">
+              <a:tr h="288000">
                 <a:tc>
                   <a:txBody>
                     <a:bodyPr/>
@@ -30492,7 +28662,7 @@
                   </a:tcPr>
                 </a:tc>
               </a:tr>
-              <a:tr h="317500">
+              <a:tr h="288000">
                 <a:tc>
                   <a:txBody>
                     <a:bodyPr/>
@@ -31036,7 +29206,7 @@
                 <a:gridCol w="2595880"/>
                 <a:gridCol w="3545840"/>
               </a:tblGrid>
-              <a:tr h="317500">
+              <a:tr h="288000">
                 <a:tc>
                   <a:txBody>
                     <a:bodyPr/>
@@ -31240,7 +29410,7 @@
                   </a:tcPr>
                 </a:tc>
               </a:tr>
-              <a:tr h="317500">
+              <a:tr h="288000">
                 <a:tc>
                   <a:txBody>
                     <a:bodyPr/>
@@ -31408,7 +29578,7 @@
                   </a:tcPr>
                 </a:tc>
               </a:tr>
-              <a:tr h="317500">
+              <a:tr h="288000">
                 <a:tc>
                   <a:txBody>
                     <a:bodyPr/>
@@ -31576,7 +29746,7 @@
                   </a:tcPr>
                 </a:tc>
               </a:tr>
-              <a:tr h="317500">
+              <a:tr h="288000">
                 <a:tc>
                   <a:txBody>
                     <a:bodyPr/>
@@ -31595,7 +29765,7 @@
                           <a:ea typeface="맑은 고딕" panose="020B0503020000020004" pitchFamily="34" charset="-127"/>
                           <a:cs typeface="맑은 고딕"/>
                         </a:rPr>
-                        <a:t>사용자 이야기</a:t>
+                        <a:t>유저 스토리</a:t>
                       </a:r>
                     </a:p>
                   </a:txBody>
@@ -31744,7 +29914,7 @@
                   </a:tcPr>
                 </a:tc>
               </a:tr>
-              <a:tr h="317500">
+              <a:tr h="288000">
                 <a:tc>
                   <a:txBody>
                     <a:bodyPr/>
@@ -31981,7 +30151,7 @@
                 <a:latin typeface="맑은 고딕"/>
                 <a:ea typeface="맑은 고딕"/>
               </a:rPr>
-              <a:t>한다. 이벤트 반응 목록, 유스케이스, 사용자 이야기, 도메인 이벤트는 모두 "무엇이 일어나면 어떤 결과가 필요한가"를 본다. 복잡한 요구도 사건과 결과는 고객과 개발자가 혼선 없이 합의할 수 있다.</a:t>
+              <a:t>한다. 이벤트 반응 목록, 유스케이스, 유저 스토리, 도메인 이벤트는 모두 "무엇이 일어나면 어떤 결과가 필요한가"를 본다. 복잡한 요구도 사건과 결과는 고객과 개발자가 혼선 없이 합의할 수 있다.</a:t>
             </a:r>
           </a:p>
         </p:txBody>
@@ -32065,7 +30235,7 @@
         </p:nvSpPr>
         <p:spPr>
           <a:xfrm>
-            <a:off x="365760" y="4046173"/>
+            <a:off x="365760" y="3898673"/>
             <a:ext cx="8412480" cy="1692593"/>
           </a:xfrm>
           <a:prstGeom prst="rect">
@@ -32413,7 +30583,7 @@
             </a:r>
           </a:p>
           <a:p>
-            <a:pPr lvl="2" marL="723900" indent="-368300">
+            <a:pPr lvl="2" marL="607060" indent="-251460">
               <a:spcBef>
                 <a:spcPts val="600"/>
               </a:spcBef>
@@ -32434,7 +30604,7 @@
             </a:r>
           </a:p>
           <a:p>
-            <a:pPr lvl="2" marL="723900" indent="-368300">
+            <a:pPr lvl="2" marL="607060" indent="-251460">
               <a:spcBef>
                 <a:spcPts val="600"/>
               </a:spcBef>
@@ -32455,7 +30625,7 @@
             </a:r>
           </a:p>
           <a:p>
-            <a:pPr lvl="2" marL="723900" indent="-368300">
+            <a:pPr lvl="2" marL="607060" indent="-251460">
               <a:spcBef>
                 <a:spcPts val="600"/>
               </a:spcBef>
@@ -32476,7 +30646,7 @@
             </a:r>
           </a:p>
           <a:p>
-            <a:pPr lvl="2" marL="723900" indent="-368300">
+            <a:pPr lvl="2" marL="607060" indent="-251460">
               <a:spcBef>
                 <a:spcPts val="600"/>
               </a:spcBef>
@@ -32497,7 +30667,7 @@
             </a:r>
           </a:p>
           <a:p>
-            <a:pPr lvl="2" marL="723900" indent="-368300">
+            <a:pPr lvl="2" marL="607060" indent="-251460">
               <a:spcBef>
                 <a:spcPts val="600"/>
               </a:spcBef>
@@ -32518,7 +30688,7 @@
             </a:r>
           </a:p>
           <a:p>
-            <a:pPr lvl="2" marL="723900" indent="-368300">
+            <a:pPr lvl="2" marL="607060" indent="-251460">
               <a:spcBef>
                 <a:spcPts val="600"/>
               </a:spcBef>

</xml_diff>